<commit_message>
Sesión 16: la Parte B del examen pasa a ser la presentación del proyecto integrador
- Examen Final [EF]: cuestionario en el Aula Virtual (10) y presentación de 7 minutos (10),
  con la entrega previa del proyecto y la bitácora de prompts
- EF_Parte_B_Pauta_de_Presentacion.pdf: guion de 5 minutos, preguntas posibles y rúbrica
- Diapositivas y guía de estudio de la sesión 16 al día; planilla de calificación del docente
- Sesión 15: la entrega del proyecto suma la bitácora de prompts y se revisa al presentarlo
- Se retiran la ficha técnica y la solución del caso práctico anterior

Co-Authored-By: Claude Opus 5.5 <noreply@anthropic.com>
Claude-Session: https://claude.ai/code/session_01DTMfh1taM2E7eRrYoW6GSd
</commit_message>
<xml_diff>
--- a/SESION 16/Sesion16-Examen-Final-Evaluacion-Integradora.pptx
+++ b/SESION 16/Sesion16-Examen-Final-Evaluacion-Integradora.pptx
@@ -8236,7 +8236,7 @@
                 <a:ea typeface="Calibri" pitchFamily="34" charset="-122"/>
                 <a:cs typeface="Calibri" pitchFamily="34" charset="-120"/>
               </a:rPr>
-              <a:t>Al volver empieza la Parte B: ten lista una carpeta vacía para tu trabajo.</a:t>
+              <a:t>Al volver empiezan las presentaciones: abre en pestañas tu sitio, tu Figma y tu bitácora.</a:t>
             </a:r>
             <a:endParaRPr lang="en-US" sz="1200" dirty="0"/>
           </a:p>
@@ -8366,7 +8366,7 @@
                 <a:ea typeface="Calibri" pitchFamily="34" charset="-122"/>
                 <a:cs typeface="Calibri" pitchFamily="34" charset="-120"/>
               </a:rPr>
-              <a:t>Parte B · Caso práctico</a:t>
+              <a:t>Parte B · Presentaciones</a:t>
             </a:r>
             <a:endParaRPr lang="en-US" sz="2000" dirty="0"/>
           </a:p>
@@ -8549,7 +8549,7 @@
                 <a:ea typeface="Calibri" pitchFamily="34" charset="-122"/>
                 <a:cs typeface="Calibri" pitchFamily="34" charset="-120"/>
               </a:rPr>
-              <a:t>La página y su ficha técnica</a:t>
+              <a:t>Tu guion de 5 minutos</a:t>
             </a:r>
             <a:endParaRPr lang="en-US" sz="1200" dirty="0"/>
           </a:p>
@@ -8759,7 +8759,7 @@
                 <a:ea typeface="Calibri" pitchFamily="34" charset="-122"/>
                 <a:cs typeface="Calibri" pitchFamily="34" charset="-120"/>
               </a:rPr>
-              <a:t>La entrega</a:t>
+              <a:t>El orden y los tiempos</a:t>
             </a:r>
             <a:endParaRPr lang="en-US" sz="1200" dirty="0"/>
           </a:p>
@@ -8954,7 +8954,7 @@
                 <a:ea typeface="Calibri" pitchFamily="34" charset="-122"/>
                 <a:cs typeface="Calibri" pitchFamily="34" charset="-120"/>
               </a:rPr>
-              <a:t>Semana de la Informática 2026</a:t>
+              <a:t>Tu guion: cinco minutos</a:t>
             </a:r>
             <a:endParaRPr lang="en-US" sz="2800" dirty="0"/>
           </a:p>
@@ -8993,7 +8993,7 @@
                 <a:ea typeface="Calibri" pitchFamily="34" charset="-122"/>
                 <a:cs typeface="Calibri" pitchFamily="34" charset="-120"/>
               </a:rPr>
-              <a:t>Una página de una sola vista. Los textos, los colores y las medidas están en la ficha técnica.</a:t>
+              <a:t>Después vienen 2 minutos de preguntas. Ensáyalo con un cronómetro.</a:t>
             </a:r>
             <a:endParaRPr lang="en-US" sz="1250" dirty="0"/>
           </a:p>
@@ -9001,24 +9001,141 @@
       </p:sp>
       <p:sp>
         <p:nvSpPr>
-          <p:cNvPr id="5" name="Shape 3"/>
+          <p:cNvPr id="5" name="Text 3"/>
+          <p:cNvSpPr txBox="1"/>
+          <p:nvPr/>
+        </p:nvSpPr>
+        <p:spPr>
+          <a:xfrm>
+            <a:off x="868680" y="2587752"/>
+            <a:ext cx="1371600" cy="219456"/>
+          </a:xfrm>
+          <a:prstGeom prst="rect">
+            <a:avLst/>
+          </a:prstGeom>
+          <a:noFill/>
+          <a:ln/>
+        </p:spPr>
+        <p:txBody>
+          <a:bodyPr wrap="square" lIns="0" tIns="0" rIns="0" bIns="0" rtlCol="0" anchor="ctr"/>
+          <a:lstStyle/>
+          <a:p>
+            <a:pPr algn="l" indent="0" marL="0">
+              <a:buNone/>
+            </a:pPr>
+            <a:r>
+              <a:rPr lang="en-US" sz="950" b="1" dirty="0">
+                <a:solidFill>
+                  <a:srgbClr val="5F676C"/>
+                </a:solidFill>
+                <a:latin typeface="Calibri" pitchFamily="34" charset="0"/>
+                <a:ea typeface="Calibri" pitchFamily="34" charset="-122"/>
+                <a:cs typeface="Calibri" pitchFamily="34" charset="-120"/>
+              </a:rPr>
+              <a:t>Tiempo</a:t>
+            </a:r>
+            <a:endParaRPr lang="en-US" sz="950" dirty="0"/>
+          </a:p>
+        </p:txBody>
+      </p:sp>
+      <p:sp>
+        <p:nvSpPr>
+          <p:cNvPr id="6" name="Text 4"/>
+          <p:cNvSpPr txBox="1"/>
+          <p:nvPr/>
+        </p:nvSpPr>
+        <p:spPr>
+          <a:xfrm>
+            <a:off x="2240280" y="2587752"/>
+            <a:ext cx="5120640" cy="219456"/>
+          </a:xfrm>
+          <a:prstGeom prst="rect">
+            <a:avLst/>
+          </a:prstGeom>
+          <a:noFill/>
+          <a:ln/>
+        </p:spPr>
+        <p:txBody>
+          <a:bodyPr wrap="square" lIns="0" tIns="0" rIns="0" bIns="0" rtlCol="0" anchor="ctr"/>
+          <a:lstStyle/>
+          <a:p>
+            <a:pPr algn="l" indent="0" marL="0">
+              <a:buNone/>
+            </a:pPr>
+            <a:r>
+              <a:rPr lang="en-US" sz="950" b="1" dirty="0">
+                <a:solidFill>
+                  <a:srgbClr val="5F676C"/>
+                </a:solidFill>
+                <a:latin typeface="Calibri" pitchFamily="34" charset="0"/>
+                <a:ea typeface="Calibri" pitchFamily="34" charset="-122"/>
+                <a:cs typeface="Calibri" pitchFamily="34" charset="-120"/>
+              </a:rPr>
+              <a:t>Qué muestras</a:t>
+            </a:r>
+            <a:endParaRPr lang="en-US" sz="950" dirty="0"/>
+          </a:p>
+        </p:txBody>
+      </p:sp>
+      <p:sp>
+        <p:nvSpPr>
+          <p:cNvPr id="7" name="Text 5"/>
+          <p:cNvSpPr txBox="1"/>
+          <p:nvPr/>
+        </p:nvSpPr>
+        <p:spPr>
+          <a:xfrm>
+            <a:off x="7360920" y="2587752"/>
+            <a:ext cx="4434840" cy="219456"/>
+          </a:xfrm>
+          <a:prstGeom prst="rect">
+            <a:avLst/>
+          </a:prstGeom>
+          <a:noFill/>
+          <a:ln/>
+        </p:spPr>
+        <p:txBody>
+          <a:bodyPr wrap="square" lIns="0" tIns="0" rIns="0" bIns="0" rtlCol="0" anchor="ctr"/>
+          <a:lstStyle/>
+          <a:p>
+            <a:pPr algn="l" indent="0" marL="0">
+              <a:buNone/>
+            </a:pPr>
+            <a:r>
+              <a:rPr lang="en-US" sz="950" b="1" dirty="0">
+                <a:solidFill>
+                  <a:srgbClr val="5F676C"/>
+                </a:solidFill>
+                <a:latin typeface="Calibri" pitchFamily="34" charset="0"/>
+                <a:ea typeface="Calibri" pitchFamily="34" charset="-122"/>
+                <a:cs typeface="Calibri" pitchFamily="34" charset="-120"/>
+              </a:rPr>
+              <a:t>Qué dices</a:t>
+            </a:r>
+            <a:endParaRPr lang="en-US" sz="950" dirty="0"/>
+          </a:p>
+        </p:txBody>
+      </p:sp>
+      <p:sp>
+        <p:nvSpPr>
+          <p:cNvPr id="8" name="Shape 6"/>
           <p:cNvSpPr/>
           <p:nvPr/>
         </p:nvSpPr>
         <p:spPr>
           <a:xfrm>
-            <a:off x="640080" y="2615184"/>
-            <a:ext cx="5618074" cy="3566160"/>
+            <a:off x="640080" y="2834640"/>
+            <a:ext cx="10927080" cy="530352"/>
           </a:xfrm>
           <a:prstGeom prst="roundRect">
             <a:avLst>
-              <a:gd name="adj" fmla="val 2564"/>
+              <a:gd name="adj" fmla="val 17241"/>
             </a:avLst>
           </a:prstGeom>
           <a:solidFill>
             <a:srgbClr val="FFFFFF"/>
           </a:solidFill>
-          <a:ln w="19050">
+          <a:ln w="12700">
             <a:solidFill>
               <a:srgbClr val="CFD5D9"/>
             </a:solidFill>
@@ -9026,50 +9143,143 @@
           </a:ln>
         </p:spPr>
       </p:sp>
-      <p:pic>
-        <p:nvPicPr>
-          <p:cNvPr id="6" name="Image 0" descr="/tmp/claude-0/-home-user-sesiones-dagner/2613c8c1-437c-54f4-94d9-b62c29473bbd/scratchpad/deck/img/s16-parte-b-1440.png">    </p:cNvPr>
-          <p:cNvPicPr>
-            <a:picLocks noChangeAspect="1"/>
-          </p:cNvPicPr>
-          <p:nvPr/>
-        </p:nvPicPr>
-        <p:blipFill>
-          <a:blip r:embed="rId1"/>
-          <a:stretch>
-            <a:fillRect/>
-          </a:stretch>
-        </p:blipFill>
-        <p:spPr>
-          <a:xfrm>
-            <a:off x="713232" y="2688336"/>
-            <a:ext cx="5471770" cy="3419856"/>
-          </a:xfrm>
-          <a:prstGeom prst="rect">
-            <a:avLst/>
-          </a:prstGeom>
-        </p:spPr>
-      </p:pic>
-      <p:sp>
-        <p:nvSpPr>
-          <p:cNvPr id="7" name="Shape 4"/>
+      <p:sp>
+        <p:nvSpPr>
+          <p:cNvPr id="9" name="Text 7"/>
+          <p:cNvSpPr txBox="1"/>
+          <p:nvPr/>
+        </p:nvSpPr>
+        <p:spPr>
+          <a:xfrm>
+            <a:off x="868680" y="2834640"/>
+            <a:ext cx="1234440" cy="530352"/>
+          </a:xfrm>
+          <a:prstGeom prst="rect">
+            <a:avLst/>
+          </a:prstGeom>
+          <a:noFill/>
+          <a:ln/>
+        </p:spPr>
+        <p:txBody>
+          <a:bodyPr wrap="square" lIns="0" tIns="0" rIns="0" bIns="0" rtlCol="0" anchor="ctr"/>
+          <a:lstStyle/>
+          <a:p>
+            <a:pPr algn="l" indent="0" marL="0">
+              <a:buNone/>
+            </a:pPr>
+            <a:r>
+              <a:rPr lang="en-US" sz="1150" b="1" dirty="0">
+                <a:solidFill>
+                  <a:srgbClr val="1F2326"/>
+                </a:solidFill>
+                <a:latin typeface="Calibri" pitchFamily="34" charset="0"/>
+                <a:ea typeface="Calibri" pitchFamily="34" charset="-122"/>
+                <a:cs typeface="Calibri" pitchFamily="34" charset="-120"/>
+              </a:rPr>
+              <a:t>30 s</a:t>
+            </a:r>
+            <a:endParaRPr lang="en-US" sz="1150" dirty="0"/>
+          </a:p>
+        </p:txBody>
+      </p:sp>
+      <p:sp>
+        <p:nvSpPr>
+          <p:cNvPr id="10" name="Text 8"/>
+          <p:cNvSpPr txBox="1"/>
+          <p:nvPr/>
+        </p:nvSpPr>
+        <p:spPr>
+          <a:xfrm>
+            <a:off x="2240280" y="2834640"/>
+            <a:ext cx="4983480" cy="530352"/>
+          </a:xfrm>
+          <a:prstGeom prst="rect">
+            <a:avLst/>
+          </a:prstGeom>
+          <a:noFill/>
+          <a:ln/>
+        </p:spPr>
+        <p:txBody>
+          <a:bodyPr wrap="square" lIns="0" tIns="0" rIns="0" bIns="0" rtlCol="0" anchor="ctr"/>
+          <a:lstStyle/>
+          <a:p>
+            <a:pPr algn="l" indent="0" marL="0">
+              <a:buNone/>
+            </a:pPr>
+            <a:r>
+              <a:rPr lang="en-US" sz="1150" dirty="0">
+                <a:solidFill>
+                  <a:srgbClr val="33393D"/>
+                </a:solidFill>
+                <a:latin typeface="Calibri" pitchFamily="34" charset="0"/>
+                <a:ea typeface="Calibri" pitchFamily="34" charset="-122"/>
+                <a:cs typeface="Calibri" pitchFamily="34" charset="-120"/>
+              </a:rPr>
+              <a:t>La página de inicio publicada</a:t>
+            </a:r>
+            <a:endParaRPr lang="en-US" sz="1150" dirty="0"/>
+          </a:p>
+        </p:txBody>
+      </p:sp>
+      <p:sp>
+        <p:nvSpPr>
+          <p:cNvPr id="11" name="Text 9"/>
+          <p:cNvSpPr txBox="1"/>
+          <p:nvPr/>
+        </p:nvSpPr>
+        <p:spPr>
+          <a:xfrm>
+            <a:off x="7360920" y="2834640"/>
+            <a:ext cx="4297680" cy="530352"/>
+          </a:xfrm>
+          <a:prstGeom prst="rect">
+            <a:avLst/>
+          </a:prstGeom>
+          <a:noFill/>
+          <a:ln/>
+        </p:spPr>
+        <p:txBody>
+          <a:bodyPr wrap="square" lIns="0" tIns="0" rIns="0" bIns="0" rtlCol="0" anchor="ctr"/>
+          <a:lstStyle/>
+          <a:p>
+            <a:pPr algn="l" indent="0" marL="0">
+              <a:buNone/>
+            </a:pPr>
+            <a:r>
+              <a:rPr lang="en-US" sz="1150" dirty="0">
+                <a:solidFill>
+                  <a:srgbClr val="33393D"/>
+                </a:solidFill>
+                <a:latin typeface="Calibri" pitchFamily="34" charset="0"/>
+                <a:ea typeface="Calibri" pitchFamily="34" charset="-122"/>
+                <a:cs typeface="Calibri" pitchFamily="34" charset="-120"/>
+              </a:rPr>
+              <a:t>Quién eres y para qué sirve tu sitio</a:t>
+            </a:r>
+            <a:endParaRPr lang="en-US" sz="1150" dirty="0"/>
+          </a:p>
+        </p:txBody>
+      </p:sp>
+      <p:sp>
+        <p:nvSpPr>
+          <p:cNvPr id="12" name="Shape 10"/>
           <p:cNvSpPr/>
           <p:nvPr/>
         </p:nvSpPr>
         <p:spPr>
           <a:xfrm>
-            <a:off x="9840591" y="2615184"/>
-            <a:ext cx="1726569" cy="3566160"/>
+            <a:off x="640080" y="3429000"/>
+            <a:ext cx="10927080" cy="530352"/>
           </a:xfrm>
           <a:prstGeom prst="roundRect">
             <a:avLst>
-              <a:gd name="adj" fmla="val 5296"/>
+              <a:gd name="adj" fmla="val 17241"/>
             </a:avLst>
           </a:prstGeom>
           <a:solidFill>
             <a:srgbClr val="FFFFFF"/>
           </a:solidFill>
-          <a:ln w="19050">
+          <a:ln w="12700">
             <a:solidFill>
               <a:srgbClr val="CFD5D9"/>
             </a:solidFill>
@@ -9077,33 +9287,558 @@
           </a:ln>
         </p:spPr>
       </p:sp>
-      <p:pic>
-        <p:nvPicPr>
-          <p:cNvPr id="8" name="Image 1" descr="La página del caso práctico en un celular">    </p:cNvPr>
-          <p:cNvPicPr>
-            <a:picLocks noChangeAspect="1"/>
-          </p:cNvPicPr>
-          <p:nvPr/>
-        </p:nvPicPr>
-        <p:blipFill>
-          <a:blip r:embed="rId2"/>
-          <a:stretch>
-            <a:fillRect/>
-          </a:stretch>
-        </p:blipFill>
-        <p:spPr>
-          <a:xfrm>
-            <a:off x="9913743" y="2688336"/>
-            <a:ext cx="1580265" cy="3419856"/>
-          </a:xfrm>
-          <a:prstGeom prst="rect">
-            <a:avLst/>
-          </a:prstGeom>
-        </p:spPr>
-      </p:pic>
-      <p:sp>
-        <p:nvSpPr>
-          <p:cNvPr id="9" name="Text 5"/>
+      <p:sp>
+        <p:nvSpPr>
+          <p:cNvPr id="13" name="Text 11"/>
+          <p:cNvSpPr txBox="1"/>
+          <p:nvPr/>
+        </p:nvSpPr>
+        <p:spPr>
+          <a:xfrm>
+            <a:off x="868680" y="3429000"/>
+            <a:ext cx="1234440" cy="530352"/>
+          </a:xfrm>
+          <a:prstGeom prst="rect">
+            <a:avLst/>
+          </a:prstGeom>
+          <a:noFill/>
+          <a:ln/>
+        </p:spPr>
+        <p:txBody>
+          <a:bodyPr wrap="square" lIns="0" tIns="0" rIns="0" bIns="0" rtlCol="0" anchor="ctr"/>
+          <a:lstStyle/>
+          <a:p>
+            <a:pPr algn="l" indent="0" marL="0">
+              <a:buNone/>
+            </a:pPr>
+            <a:r>
+              <a:rPr lang="en-US" sz="1150" b="1" dirty="0">
+                <a:solidFill>
+                  <a:srgbClr val="1F2326"/>
+                </a:solidFill>
+                <a:latin typeface="Calibri" pitchFamily="34" charset="0"/>
+                <a:ea typeface="Calibri" pitchFamily="34" charset="-122"/>
+                <a:cs typeface="Calibri" pitchFamily="34" charset="-120"/>
+              </a:rPr>
+              <a:t>1 min</a:t>
+            </a:r>
+            <a:endParaRPr lang="en-US" sz="1150" dirty="0"/>
+          </a:p>
+        </p:txBody>
+      </p:sp>
+      <p:sp>
+        <p:nvSpPr>
+          <p:cNvPr id="14" name="Text 12"/>
+          <p:cNvSpPr txBox="1"/>
+          <p:nvPr/>
+        </p:nvSpPr>
+        <p:spPr>
+          <a:xfrm>
+            <a:off x="2240280" y="3429000"/>
+            <a:ext cx="4983480" cy="530352"/>
+          </a:xfrm>
+          <a:prstGeom prst="rect">
+            <a:avLst/>
+          </a:prstGeom>
+          <a:noFill/>
+          <a:ln/>
+        </p:spPr>
+        <p:txBody>
+          <a:bodyPr wrap="square" lIns="0" tIns="0" rIns="0" bIns="0" rtlCol="0" anchor="ctr"/>
+          <a:lstStyle/>
+          <a:p>
+            <a:pPr algn="l" indent="0" marL="0">
+              <a:buNone/>
+            </a:pPr>
+            <a:r>
+              <a:rPr lang="en-US" sz="1150" dirty="0">
+                <a:solidFill>
+                  <a:srgbClr val="33393D"/>
+                </a:solidFill>
+                <a:latin typeface="Calibri" pitchFamily="34" charset="0"/>
+                <a:ea typeface="Calibri" pitchFamily="34" charset="-122"/>
+                <a:cs typeface="Calibri" pitchFamily="34" charset="-120"/>
+              </a:rPr>
+              <a:t>Tu Figma: escritorio, celular y un componente</a:t>
+            </a:r>
+            <a:endParaRPr lang="en-US" sz="1150" dirty="0"/>
+          </a:p>
+        </p:txBody>
+      </p:sp>
+      <p:sp>
+        <p:nvSpPr>
+          <p:cNvPr id="15" name="Text 13"/>
+          <p:cNvSpPr txBox="1"/>
+          <p:nvPr/>
+        </p:nvSpPr>
+        <p:spPr>
+          <a:xfrm>
+            <a:off x="7360920" y="3429000"/>
+            <a:ext cx="4297680" cy="530352"/>
+          </a:xfrm>
+          <a:prstGeom prst="rect">
+            <a:avLst/>
+          </a:prstGeom>
+          <a:noFill/>
+          <a:ln/>
+        </p:spPr>
+        <p:txBody>
+          <a:bodyPr wrap="square" lIns="0" tIns="0" rIns="0" bIns="0" rtlCol="0" anchor="ctr"/>
+          <a:lstStyle/>
+          <a:p>
+            <a:pPr algn="l" indent="0" marL="0">
+              <a:buNone/>
+            </a:pPr>
+            <a:r>
+              <a:rPr lang="en-US" sz="1150" dirty="0">
+                <a:solidFill>
+                  <a:srgbClr val="33393D"/>
+                </a:solidFill>
+                <a:latin typeface="Calibri" pitchFamily="34" charset="0"/>
+                <a:ea typeface="Calibri" pitchFamily="34" charset="-122"/>
+                <a:cs typeface="Calibri" pitchFamily="34" charset="-120"/>
+              </a:rPr>
+              <a:t>Cómo pasaste sus valores al código</a:t>
+            </a:r>
+            <a:endParaRPr lang="en-US" sz="1150" dirty="0"/>
+          </a:p>
+        </p:txBody>
+      </p:sp>
+      <p:sp>
+        <p:nvSpPr>
+          <p:cNvPr id="16" name="Shape 14"/>
+          <p:cNvSpPr/>
+          <p:nvPr/>
+        </p:nvSpPr>
+        <p:spPr>
+          <a:xfrm>
+            <a:off x="640080" y="4023360"/>
+            <a:ext cx="10927080" cy="530352"/>
+          </a:xfrm>
+          <a:prstGeom prst="roundRect">
+            <a:avLst>
+              <a:gd name="adj" fmla="val 17241"/>
+            </a:avLst>
+          </a:prstGeom>
+          <a:solidFill>
+            <a:srgbClr val="FFFFFF"/>
+          </a:solidFill>
+          <a:ln w="12700">
+            <a:solidFill>
+              <a:srgbClr val="CFD5D9"/>
+            </a:solidFill>
+            <a:prstDash val="solid"/>
+          </a:ln>
+        </p:spPr>
+      </p:sp>
+      <p:sp>
+        <p:nvSpPr>
+          <p:cNvPr id="17" name="Text 15"/>
+          <p:cNvSpPr txBox="1"/>
+          <p:nvPr/>
+        </p:nvSpPr>
+        <p:spPr>
+          <a:xfrm>
+            <a:off x="868680" y="4023360"/>
+            <a:ext cx="1234440" cy="530352"/>
+          </a:xfrm>
+          <a:prstGeom prst="rect">
+            <a:avLst/>
+          </a:prstGeom>
+          <a:noFill/>
+          <a:ln/>
+        </p:spPr>
+        <p:txBody>
+          <a:bodyPr wrap="square" lIns="0" tIns="0" rIns="0" bIns="0" rtlCol="0" anchor="ctr"/>
+          <a:lstStyle/>
+          <a:p>
+            <a:pPr algn="l" indent="0" marL="0">
+              <a:buNone/>
+            </a:pPr>
+            <a:r>
+              <a:rPr lang="en-US" sz="1150" b="1" dirty="0">
+                <a:solidFill>
+                  <a:srgbClr val="1F2326"/>
+                </a:solidFill>
+                <a:latin typeface="Calibri" pitchFamily="34" charset="0"/>
+                <a:ea typeface="Calibri" pitchFamily="34" charset="-122"/>
+                <a:cs typeface="Calibri" pitchFamily="34" charset="-120"/>
+              </a:rPr>
+              <a:t>2 min</a:t>
+            </a:r>
+            <a:endParaRPr lang="en-US" sz="1150" dirty="0"/>
+          </a:p>
+        </p:txBody>
+      </p:sp>
+      <p:sp>
+        <p:nvSpPr>
+          <p:cNvPr id="18" name="Text 16"/>
+          <p:cNvSpPr txBox="1"/>
+          <p:nvPr/>
+        </p:nvSpPr>
+        <p:spPr>
+          <a:xfrm>
+            <a:off x="2240280" y="4023360"/>
+            <a:ext cx="4983480" cy="530352"/>
+          </a:xfrm>
+          <a:prstGeom prst="rect">
+            <a:avLst/>
+          </a:prstGeom>
+          <a:noFill/>
+          <a:ln/>
+        </p:spPr>
+        <p:txBody>
+          <a:bodyPr wrap="square" lIns="0" tIns="0" rIns="0" bIns="0" rtlCol="0" anchor="ctr"/>
+          <a:lstStyle/>
+          <a:p>
+            <a:pPr algn="l" indent="0" marL="0">
+              <a:buNone/>
+            </a:pPr>
+            <a:r>
+              <a:rPr lang="en-US" sz="1150" dirty="0">
+                <a:solidFill>
+                  <a:srgbClr val="33393D"/>
+                </a:solidFill>
+                <a:latin typeface="Calibri" pitchFamily="34" charset="0"/>
+                <a:ea typeface="Calibri" pitchFamily="34" charset="-122"/>
+                <a:cs typeface="Calibri" pitchFamily="34" charset="-120"/>
+              </a:rPr>
+              <a:t>El sitio: páginas, un hover, el celular con F12 y el formulario</a:t>
+            </a:r>
+            <a:endParaRPr lang="en-US" sz="1150" dirty="0"/>
+          </a:p>
+        </p:txBody>
+      </p:sp>
+      <p:sp>
+        <p:nvSpPr>
+          <p:cNvPr id="19" name="Text 17"/>
+          <p:cNvSpPr txBox="1"/>
+          <p:nvPr/>
+        </p:nvSpPr>
+        <p:spPr>
+          <a:xfrm>
+            <a:off x="7360920" y="4023360"/>
+            <a:ext cx="4297680" cy="530352"/>
+          </a:xfrm>
+          <a:prstGeom prst="rect">
+            <a:avLst/>
+          </a:prstGeom>
+          <a:noFill/>
+          <a:ln/>
+        </p:spPr>
+        <p:txBody>
+          <a:bodyPr wrap="square" lIns="0" tIns="0" rIns="0" bIns="0" rtlCol="0" anchor="ctr"/>
+          <a:lstStyle/>
+          <a:p>
+            <a:pPr algn="l" indent="0" marL="0">
+              <a:buNone/>
+            </a:pPr>
+            <a:r>
+              <a:rPr lang="en-US" sz="1150" dirty="0">
+                <a:solidFill>
+                  <a:srgbClr val="33393D"/>
+                </a:solidFill>
+                <a:latin typeface="Calibri" pitchFamily="34" charset="0"/>
+                <a:ea typeface="Calibri" pitchFamily="34" charset="-122"/>
+                <a:cs typeface="Calibri" pitchFamily="34" charset="-120"/>
+              </a:rPr>
+              <a:t>Qué técnica usaste en cada parte</a:t>
+            </a:r>
+            <a:endParaRPr lang="en-US" sz="1150" dirty="0"/>
+          </a:p>
+        </p:txBody>
+      </p:sp>
+      <p:sp>
+        <p:nvSpPr>
+          <p:cNvPr id="20" name="Shape 18"/>
+          <p:cNvSpPr/>
+          <p:nvPr/>
+        </p:nvSpPr>
+        <p:spPr>
+          <a:xfrm>
+            <a:off x="640080" y="4617720"/>
+            <a:ext cx="10927080" cy="530352"/>
+          </a:xfrm>
+          <a:prstGeom prst="roundRect">
+            <a:avLst>
+              <a:gd name="adj" fmla="val 17241"/>
+            </a:avLst>
+          </a:prstGeom>
+          <a:solidFill>
+            <a:srgbClr val="FFFFFF"/>
+          </a:solidFill>
+          <a:ln w="12700">
+            <a:solidFill>
+              <a:srgbClr val="CFD5D9"/>
+            </a:solidFill>
+            <a:prstDash val="solid"/>
+          </a:ln>
+        </p:spPr>
+      </p:sp>
+      <p:sp>
+        <p:nvSpPr>
+          <p:cNvPr id="21" name="Text 19"/>
+          <p:cNvSpPr txBox="1"/>
+          <p:nvPr/>
+        </p:nvSpPr>
+        <p:spPr>
+          <a:xfrm>
+            <a:off x="868680" y="4617720"/>
+            <a:ext cx="1234440" cy="530352"/>
+          </a:xfrm>
+          <a:prstGeom prst="rect">
+            <a:avLst/>
+          </a:prstGeom>
+          <a:noFill/>
+          <a:ln/>
+        </p:spPr>
+        <p:txBody>
+          <a:bodyPr wrap="square" lIns="0" tIns="0" rIns="0" bIns="0" rtlCol="0" anchor="ctr"/>
+          <a:lstStyle/>
+          <a:p>
+            <a:pPr algn="l" indent="0" marL="0">
+              <a:buNone/>
+            </a:pPr>
+            <a:r>
+              <a:rPr lang="en-US" sz="1150" b="1" dirty="0">
+                <a:solidFill>
+                  <a:srgbClr val="1F2326"/>
+                </a:solidFill>
+                <a:latin typeface="Calibri" pitchFamily="34" charset="0"/>
+                <a:ea typeface="Calibri" pitchFamily="34" charset="-122"/>
+                <a:cs typeface="Calibri" pitchFamily="34" charset="-120"/>
+              </a:rPr>
+              <a:t>1 min</a:t>
+            </a:r>
+            <a:endParaRPr lang="en-US" sz="1150" dirty="0"/>
+          </a:p>
+        </p:txBody>
+      </p:sp>
+      <p:sp>
+        <p:nvSpPr>
+          <p:cNvPr id="22" name="Text 20"/>
+          <p:cNvSpPr txBox="1"/>
+          <p:nvPr/>
+        </p:nvSpPr>
+        <p:spPr>
+          <a:xfrm>
+            <a:off x="2240280" y="4617720"/>
+            <a:ext cx="4983480" cy="530352"/>
+          </a:xfrm>
+          <a:prstGeom prst="rect">
+            <a:avLst/>
+          </a:prstGeom>
+          <a:noFill/>
+          <a:ln/>
+        </p:spPr>
+        <p:txBody>
+          <a:bodyPr wrap="square" lIns="0" tIns="0" rIns="0" bIns="0" rtlCol="0" anchor="ctr"/>
+          <a:lstStyle/>
+          <a:p>
+            <a:pPr algn="l" indent="0" marL="0">
+              <a:buNone/>
+            </a:pPr>
+            <a:r>
+              <a:rPr lang="en-US" sz="1150" dirty="0">
+                <a:solidFill>
+                  <a:srgbClr val="33393D"/>
+                </a:solidFill>
+                <a:latin typeface="Calibri" pitchFamily="34" charset="0"/>
+                <a:ea typeface="Calibri" pitchFamily="34" charset="-122"/>
+                <a:cs typeface="Calibri" pitchFamily="34" charset="-120"/>
+              </a:rPr>
+              <a:t>Tu bitácora: tu mejor prompt</a:t>
+            </a:r>
+            <a:endParaRPr lang="en-US" sz="1150" dirty="0"/>
+          </a:p>
+        </p:txBody>
+      </p:sp>
+      <p:sp>
+        <p:nvSpPr>
+          <p:cNvPr id="23" name="Text 21"/>
+          <p:cNvSpPr txBox="1"/>
+          <p:nvPr/>
+        </p:nvSpPr>
+        <p:spPr>
+          <a:xfrm>
+            <a:off x="7360920" y="4617720"/>
+            <a:ext cx="4297680" cy="530352"/>
+          </a:xfrm>
+          <a:prstGeom prst="rect">
+            <a:avLst/>
+          </a:prstGeom>
+          <a:noFill/>
+          <a:ln/>
+        </p:spPr>
+        <p:txBody>
+          <a:bodyPr wrap="square" lIns="0" tIns="0" rIns="0" bIns="0" rtlCol="0" anchor="ctr"/>
+          <a:lstStyle/>
+          <a:p>
+            <a:pPr algn="l" indent="0" marL="0">
+              <a:buNone/>
+            </a:pPr>
+            <a:r>
+              <a:rPr lang="en-US" sz="1150" dirty="0">
+                <a:solidFill>
+                  <a:srgbClr val="33393D"/>
+                </a:solidFill>
+                <a:latin typeface="Calibri" pitchFamily="34" charset="0"/>
+                <a:ea typeface="Calibri" pitchFamily="34" charset="-122"/>
+                <a:cs typeface="Calibri" pitchFamily="34" charset="-120"/>
+              </a:rPr>
+              <a:t>Qué pediste, qué corregiste y cómo lo comprobaste</a:t>
+            </a:r>
+            <a:endParaRPr lang="en-US" sz="1150" dirty="0"/>
+          </a:p>
+        </p:txBody>
+      </p:sp>
+      <p:sp>
+        <p:nvSpPr>
+          <p:cNvPr id="24" name="Shape 22"/>
+          <p:cNvSpPr/>
+          <p:nvPr/>
+        </p:nvSpPr>
+        <p:spPr>
+          <a:xfrm>
+            <a:off x="640080" y="5212080"/>
+            <a:ext cx="10927080" cy="530352"/>
+          </a:xfrm>
+          <a:prstGeom prst="roundRect">
+            <a:avLst>
+              <a:gd name="adj" fmla="val 17241"/>
+            </a:avLst>
+          </a:prstGeom>
+          <a:solidFill>
+            <a:srgbClr val="FFFFFF"/>
+          </a:solidFill>
+          <a:ln w="12700">
+            <a:solidFill>
+              <a:srgbClr val="CFD5D9"/>
+            </a:solidFill>
+            <a:prstDash val="solid"/>
+          </a:ln>
+        </p:spPr>
+      </p:sp>
+      <p:sp>
+        <p:nvSpPr>
+          <p:cNvPr id="25" name="Text 23"/>
+          <p:cNvSpPr txBox="1"/>
+          <p:nvPr/>
+        </p:nvSpPr>
+        <p:spPr>
+          <a:xfrm>
+            <a:off x="868680" y="5212080"/>
+            <a:ext cx="1234440" cy="530352"/>
+          </a:xfrm>
+          <a:prstGeom prst="rect">
+            <a:avLst/>
+          </a:prstGeom>
+          <a:noFill/>
+          <a:ln/>
+        </p:spPr>
+        <p:txBody>
+          <a:bodyPr wrap="square" lIns="0" tIns="0" rIns="0" bIns="0" rtlCol="0" anchor="ctr"/>
+          <a:lstStyle/>
+          <a:p>
+            <a:pPr algn="l" indent="0" marL="0">
+              <a:buNone/>
+            </a:pPr>
+            <a:r>
+              <a:rPr lang="en-US" sz="1150" b="1" dirty="0">
+                <a:solidFill>
+                  <a:srgbClr val="1F2326"/>
+                </a:solidFill>
+                <a:latin typeface="Calibri" pitchFamily="34" charset="0"/>
+                <a:ea typeface="Calibri" pitchFamily="34" charset="-122"/>
+                <a:cs typeface="Calibri" pitchFamily="34" charset="-120"/>
+              </a:rPr>
+              <a:t>30 s</a:t>
+            </a:r>
+            <a:endParaRPr lang="en-US" sz="1150" dirty="0"/>
+          </a:p>
+        </p:txBody>
+      </p:sp>
+      <p:sp>
+        <p:nvSpPr>
+          <p:cNvPr id="26" name="Text 24"/>
+          <p:cNvSpPr txBox="1"/>
+          <p:nvPr/>
+        </p:nvSpPr>
+        <p:spPr>
+          <a:xfrm>
+            <a:off x="2240280" y="5212080"/>
+            <a:ext cx="4983480" cy="530352"/>
+          </a:xfrm>
+          <a:prstGeom prst="rect">
+            <a:avLst/>
+          </a:prstGeom>
+          <a:noFill/>
+          <a:ln/>
+        </p:spPr>
+        <p:txBody>
+          <a:bodyPr wrap="square" lIns="0" tIns="0" rIns="0" bIns="0" rtlCol="0" anchor="ctr"/>
+          <a:lstStyle/>
+          <a:p>
+            <a:pPr algn="l" indent="0" marL="0">
+              <a:buNone/>
+            </a:pPr>
+            <a:r>
+              <a:rPr lang="en-US" sz="1150" dirty="0">
+                <a:solidFill>
+                  <a:srgbClr val="33393D"/>
+                </a:solidFill>
+                <a:latin typeface="Calibri" pitchFamily="34" charset="0"/>
+                <a:ea typeface="Calibri" pitchFamily="34" charset="-122"/>
+                <a:cs typeface="Calibri" pitchFamily="34" charset="-120"/>
+              </a:rPr>
+              <a:t>Tu captura de Lighthouse</a:t>
+            </a:r>
+            <a:endParaRPr lang="en-US" sz="1150" dirty="0"/>
+          </a:p>
+        </p:txBody>
+      </p:sp>
+      <p:sp>
+        <p:nvSpPr>
+          <p:cNvPr id="27" name="Text 25"/>
+          <p:cNvSpPr txBox="1"/>
+          <p:nvPr/>
+        </p:nvSpPr>
+        <p:spPr>
+          <a:xfrm>
+            <a:off x="7360920" y="5212080"/>
+            <a:ext cx="4297680" cy="530352"/>
+          </a:xfrm>
+          <a:prstGeom prst="rect">
+            <a:avLst/>
+          </a:prstGeom>
+          <a:noFill/>
+          <a:ln/>
+        </p:spPr>
+        <p:txBody>
+          <a:bodyPr wrap="square" lIns="0" tIns="0" rIns="0" bIns="0" rtlCol="0" anchor="ctr"/>
+          <a:lstStyle/>
+          <a:p>
+            <a:pPr algn="l" indent="0" marL="0">
+              <a:buNone/>
+            </a:pPr>
+            <a:r>
+              <a:rPr lang="en-US" sz="1150" dirty="0">
+                <a:solidFill>
+                  <a:srgbClr val="33393D"/>
+                </a:solidFill>
+                <a:latin typeface="Calibri" pitchFamily="34" charset="0"/>
+                <a:ea typeface="Calibri" pitchFamily="34" charset="-122"/>
+                <a:cs typeface="Calibri" pitchFamily="34" charset="-120"/>
+              </a:rPr>
+              <a:t>Qué mejorarías con una semana más</a:t>
+            </a:r>
+            <a:endParaRPr lang="en-US" sz="1150" dirty="0"/>
+          </a:p>
+        </p:txBody>
+      </p:sp>
+      <p:sp>
+        <p:nvSpPr>
+          <p:cNvPr id="28" name="Text 26"/>
           <p:cNvSpPr txBox="1"/>
           <p:nvPr/>
         </p:nvSpPr>
@@ -9461,7 +10196,7 @@
                 <a:ea typeface="Calibri" pitchFamily="34" charset="-122"/>
                 <a:cs typeface="Calibri" pitchFamily="34" charset="-120"/>
               </a:rPr>
-              <a:t>Estructura semántica</a:t>
+              <a:t>Sitio publicado y funcional</a:t>
             </a:r>
             <a:endParaRPr lang="en-US" sz="1150" dirty="0"/>
           </a:p>
@@ -9500,7 +10235,7 @@
                 <a:ea typeface="Calibri" pitchFamily="34" charset="-122"/>
                 <a:cs typeface="Calibri" pitchFamily="34" charset="-120"/>
               </a:rPr>
-              <a:t>header, nav, main, section, article y footer; un solo h1; sin errores en el validador</a:t>
+              <a:t>En Netlify: enlaces, celular a 390 px, formulario que guarda mensajes y página 404</a:t>
             </a:r>
             <a:endParaRPr lang="en-US" sz="1150" dirty="0"/>
           </a:p>
@@ -9605,7 +10340,7 @@
                 <a:ea typeface="Calibri" pitchFamily="34" charset="-122"/>
                 <a:cs typeface="Calibri" pitchFamily="34" charset="-120"/>
               </a:rPr>
-              <a:t>Estilos y variables</a:t>
+              <a:t>Diseño y fidelidad</a:t>
             </a:r>
             <a:endParaRPr lang="en-US" sz="1150" dirty="0"/>
           </a:p>
@@ -9644,7 +10379,7 @@
                 <a:ea typeface="Calibri" pitchFamily="34" charset="-122"/>
                 <a:cs typeface="Calibri" pitchFamily="34" charset="-120"/>
               </a:rPr>
-              <a:t>CSS externo, los valores de la ficha como variables en :root, las dos fuentes</a:t>
+              <a:t>Figma con escritorio, celular y componentes; el sitio respeta sus colores y medidas</a:t>
             </a:r>
             <a:endParaRPr lang="en-US" sz="1150" dirty="0"/>
           </a:p>
@@ -9749,7 +10484,7 @@
                 <a:ea typeface="Calibri" pitchFamily="34" charset="-122"/>
                 <a:cs typeface="Calibri" pitchFamily="34" charset="-120"/>
               </a:rPr>
-              <a:t>Maquetación</a:t>
+              <a:t>Código y pruebas</a:t>
             </a:r>
             <a:endParaRPr lang="en-US" sz="1150" dirty="0"/>
           </a:p>
@@ -9788,7 +10523,7 @@
                 <a:ea typeface="Calibri" pitchFamily="34" charset="-122"/>
                 <a:cs typeface="Calibri" pitchFamily="34" charset="-120"/>
               </a:rPr>
-              <a:t>Cabecera con Flexbox; charlas con grid o con la grilla de Bootstrap</a:t>
+              <a:t>HTML válido; explica la parte del código que se le pide; Lighthouse 90+ en Accesibilidad</a:t>
             </a:r>
             <a:endParaRPr lang="en-US" sz="1150" dirty="0"/>
           </a:p>
@@ -9893,7 +10628,7 @@
                 <a:ea typeface="Calibri" pitchFamily="34" charset="-122"/>
                 <a:cs typeface="Calibri" pitchFamily="34" charset="-120"/>
               </a:rPr>
-              <a:t>Diseño adaptable</a:t>
+              <a:t>Uso responsable de la IA</a:t>
             </a:r>
             <a:endParaRPr lang="en-US" sz="1150" dirty="0"/>
           </a:p>
@@ -9932,7 +10667,7 @@
                 <a:ea typeface="Calibri" pitchFamily="34" charset="-122"/>
                 <a:cs typeface="Calibri" pitchFamily="34" charset="-120"/>
               </a:rPr>
-              <a:t>viewport y una media query: charlas en una columna, sin barra horizontal a 390px</a:t>
+              <a:t>Bitácora con 3 prompts o más: qué pidió, qué corrigió y cómo lo comprobó</a:t>
             </a:r>
             <a:endParaRPr lang="en-US" sz="1150" dirty="0"/>
           </a:p>
@@ -10037,7 +10772,7 @@
                 <a:ea typeface="Calibri" pitchFamily="34" charset="-122"/>
                 <a:cs typeface="Calibri" pitchFamily="34" charset="-120"/>
               </a:rPr>
-              <a:t>Interacción y formulario</a:t>
+              <a:t>Presentación</a:t>
             </a:r>
             <a:endParaRPr lang="en-US" sz="1150" dirty="0"/>
           </a:p>
@@ -10076,7 +10811,7 @@
                 <a:ea typeface="Calibri" pitchFamily="34" charset="-122"/>
                 <a:cs typeface="Calibri" pitchFamily="34" charset="-120"/>
               </a:rPr>
-              <a:t>Hover con transition; campos con label, name y required; type="email"</a:t>
+              <a:t>Sigue el guion en 5 minutos, con orden y claridad; responde las preguntas</a:t>
             </a:r>
             <a:endParaRPr lang="en-US" sz="1150" dirty="0"/>
           </a:p>
@@ -10392,7 +11127,7 @@
                 <a:ea typeface="Calibri" pitchFamily="34" charset="-122"/>
                 <a:cs typeface="Calibri" pitchFamily="34" charset="-120"/>
               </a:rPr>
-              <a:t>Cómo repartir los 80 minutos</a:t>
+              <a:t>El orden y los tiempos</a:t>
             </a:r>
             <a:endParaRPr lang="en-US" sz="2800" dirty="0"/>
           </a:p>
@@ -10431,7 +11166,7 @@
                 <a:ea typeface="Calibri" pitchFamily="34" charset="-122"/>
                 <a:cs typeface="Calibri" pitchFamily="34" charset="-120"/>
               </a:rPr>
-              <a:t>Deja los últimos 5 minutos solo para comprimir y subir.</a:t>
+              <a:t>Siete minutos por proyecto. Mientras uno presenta, el siguiente se prepara.</a:t>
             </a:r>
             <a:endParaRPr lang="en-US" sz="1250" dirty="0"/>
           </a:p>
@@ -10439,135 +11174,18 @@
       </p:sp>
       <p:sp>
         <p:nvSpPr>
-          <p:cNvPr id="5" name="Text 3"/>
-          <p:cNvSpPr txBox="1"/>
-          <p:nvPr/>
-        </p:nvSpPr>
-        <p:spPr>
-          <a:xfrm>
-            <a:off x="868680" y="2587752"/>
-            <a:ext cx="1463040" cy="219456"/>
-          </a:xfrm>
-          <a:prstGeom prst="rect">
-            <a:avLst/>
-          </a:prstGeom>
-          <a:noFill/>
-          <a:ln/>
-        </p:spPr>
-        <p:txBody>
-          <a:bodyPr wrap="square" lIns="0" tIns="0" rIns="0" bIns="0" rtlCol="0" anchor="ctr"/>
-          <a:lstStyle/>
-          <a:p>
-            <a:pPr algn="l" indent="0" marL="0">
-              <a:buNone/>
-            </a:pPr>
-            <a:r>
-              <a:rPr lang="en-US" sz="950" b="1" dirty="0">
-                <a:solidFill>
-                  <a:srgbClr val="5F676C"/>
-                </a:solidFill>
-                <a:latin typeface="Calibri" pitchFamily="34" charset="0"/>
-                <a:ea typeface="Calibri" pitchFamily="34" charset="-122"/>
-                <a:cs typeface="Calibri" pitchFamily="34" charset="-120"/>
-              </a:rPr>
-              <a:t>Minutos</a:t>
-            </a:r>
-            <a:endParaRPr lang="en-US" sz="950" dirty="0"/>
-          </a:p>
-        </p:txBody>
-      </p:sp>
-      <p:sp>
-        <p:nvSpPr>
-          <p:cNvPr id="6" name="Text 4"/>
-          <p:cNvSpPr txBox="1"/>
-          <p:nvPr/>
-        </p:nvSpPr>
-        <p:spPr>
-          <a:xfrm>
-            <a:off x="2331720" y="2587752"/>
-            <a:ext cx="6675120" cy="219456"/>
-          </a:xfrm>
-          <a:prstGeom prst="rect">
-            <a:avLst/>
-          </a:prstGeom>
-          <a:noFill/>
-          <a:ln/>
-        </p:spPr>
-        <p:txBody>
-          <a:bodyPr wrap="square" lIns="0" tIns="0" rIns="0" bIns="0" rtlCol="0" anchor="ctr"/>
-          <a:lstStyle/>
-          <a:p>
-            <a:pPr algn="l" indent="0" marL="0">
-              <a:buNone/>
-            </a:pPr>
-            <a:r>
-              <a:rPr lang="en-US" sz="950" b="1" dirty="0">
-                <a:solidFill>
-                  <a:srgbClr val="5F676C"/>
-                </a:solidFill>
-                <a:latin typeface="Calibri" pitchFamily="34" charset="0"/>
-                <a:ea typeface="Calibri" pitchFamily="34" charset="-122"/>
-                <a:cs typeface="Calibri" pitchFamily="34" charset="-120"/>
-              </a:rPr>
-              <a:t>Qué haces</a:t>
-            </a:r>
-            <a:endParaRPr lang="en-US" sz="950" dirty="0"/>
-          </a:p>
-        </p:txBody>
-      </p:sp>
-      <p:sp>
-        <p:nvSpPr>
-          <p:cNvPr id="7" name="Text 5"/>
-          <p:cNvSpPr txBox="1"/>
-          <p:nvPr/>
-        </p:nvSpPr>
-        <p:spPr>
-          <a:xfrm>
-            <a:off x="9006840" y="2587752"/>
-            <a:ext cx="2788920" cy="219456"/>
-          </a:xfrm>
-          <a:prstGeom prst="rect">
-            <a:avLst/>
-          </a:prstGeom>
-          <a:noFill/>
-          <a:ln/>
-        </p:spPr>
-        <p:txBody>
-          <a:bodyPr wrap="square" lIns="0" tIns="0" rIns="0" bIns="0" rtlCol="0" anchor="ctr"/>
-          <a:lstStyle/>
-          <a:p>
-            <a:pPr algn="l" indent="0" marL="0">
-              <a:buNone/>
-            </a:pPr>
-            <a:r>
-              <a:rPr lang="en-US" sz="950" b="1" dirty="0">
-                <a:solidFill>
-                  <a:srgbClr val="5F676C"/>
-                </a:solidFill>
-                <a:latin typeface="Calibri" pitchFamily="34" charset="0"/>
-                <a:ea typeface="Calibri" pitchFamily="34" charset="-122"/>
-                <a:cs typeface="Calibri" pitchFamily="34" charset="-120"/>
-              </a:rPr>
-              <a:t>Criterio</a:t>
-            </a:r>
-            <a:endParaRPr lang="en-US" sz="950" dirty="0"/>
-          </a:p>
-        </p:txBody>
-      </p:sp>
-      <p:sp>
-        <p:nvSpPr>
-          <p:cNvPr id="8" name="Shape 6"/>
+          <p:cNvPr id="5" name="Shape 3"/>
           <p:cNvSpPr/>
           <p:nvPr/>
         </p:nvSpPr>
         <p:spPr>
           <a:xfrm>
-            <a:off x="640080" y="2834640"/>
-            <a:ext cx="10927080" cy="457200"/>
+            <a:off x="640080" y="2615184"/>
+            <a:ext cx="3520440" cy="1572768"/>
           </a:xfrm>
           <a:prstGeom prst="roundRect">
             <a:avLst>
-              <a:gd name="adj" fmla="val 20000"/>
+              <a:gd name="adj" fmla="val 5814"/>
             </a:avLst>
           </a:prstGeom>
           <a:solidFill>
@@ -10583,38 +11201,141 @@
       </p:sp>
       <p:sp>
         <p:nvSpPr>
+          <p:cNvPr id="6" name="Shape 4"/>
+          <p:cNvSpPr/>
+          <p:nvPr/>
+        </p:nvSpPr>
+        <p:spPr>
+          <a:xfrm>
+            <a:off x="886968" y="2843784"/>
+            <a:ext cx="402336" cy="402336"/>
+          </a:xfrm>
+          <a:prstGeom prst="ellipse">
+            <a:avLst/>
+          </a:prstGeom>
+          <a:solidFill>
+            <a:srgbClr val="177E89"/>
+          </a:solidFill>
+          <a:ln w="12700">
+            <a:solidFill>
+              <a:srgbClr val="177E89"/>
+            </a:solidFill>
+            <a:prstDash val="solid"/>
+          </a:ln>
+        </p:spPr>
+      </p:sp>
+      <p:sp>
+        <p:nvSpPr>
+          <p:cNvPr id="7" name="Text 5"/>
+          <p:cNvSpPr txBox="1"/>
+          <p:nvPr/>
+        </p:nvSpPr>
+        <p:spPr>
+          <a:xfrm>
+            <a:off x="886968" y="2843784"/>
+            <a:ext cx="402336" cy="402336"/>
+          </a:xfrm>
+          <a:prstGeom prst="rect">
+            <a:avLst/>
+          </a:prstGeom>
+          <a:noFill/>
+          <a:ln/>
+        </p:spPr>
+        <p:txBody>
+          <a:bodyPr wrap="square" lIns="0" tIns="0" rIns="0" bIns="0" rtlCol="0" anchor="ctr"/>
+          <a:lstStyle/>
+          <a:p>
+            <a:pPr algn="ctr" indent="0" marL="0">
+              <a:buNone/>
+            </a:pPr>
+            <a:r>
+              <a:rPr lang="en-US" sz="1200" b="1" dirty="0">
+                <a:solidFill>
+                  <a:srgbClr val="FFFFFF"/>
+                </a:solidFill>
+                <a:latin typeface="Calibri" pitchFamily="34" charset="0"/>
+                <a:ea typeface="Calibri" pitchFamily="34" charset="-122"/>
+                <a:cs typeface="Calibri" pitchFamily="34" charset="-120"/>
+              </a:rPr>
+              <a:t>1</a:t>
+            </a:r>
+            <a:endParaRPr lang="en-US" sz="1200" dirty="0"/>
+          </a:p>
+        </p:txBody>
+      </p:sp>
+      <p:sp>
+        <p:nvSpPr>
+          <p:cNvPr id="8" name="Text 6"/>
+          <p:cNvSpPr txBox="1"/>
+          <p:nvPr/>
+        </p:nvSpPr>
+        <p:spPr>
+          <a:xfrm>
+            <a:off x="1444752" y="2843784"/>
+            <a:ext cx="2560320" cy="402336"/>
+          </a:xfrm>
+          <a:prstGeom prst="rect">
+            <a:avLst/>
+          </a:prstGeom>
+          <a:noFill/>
+          <a:ln/>
+        </p:spPr>
+        <p:txBody>
+          <a:bodyPr wrap="square" lIns="0" tIns="0" rIns="0" bIns="0" rtlCol="0" anchor="ctr"/>
+          <a:lstStyle/>
+          <a:p>
+            <a:pPr algn="l" indent="0" marL="0">
+              <a:buNone/>
+            </a:pPr>
+            <a:r>
+              <a:rPr lang="en-US" sz="1300" b="1" dirty="0">
+                <a:solidFill>
+                  <a:srgbClr val="1F2326"/>
+                </a:solidFill>
+                <a:latin typeface="Calibri" pitchFamily="34" charset="0"/>
+                <a:ea typeface="Calibri" pitchFamily="34" charset="-122"/>
+                <a:cs typeface="Calibri" pitchFamily="34" charset="-120"/>
+              </a:rPr>
+              <a:t>Sorteo</a:t>
+            </a:r>
+            <a:endParaRPr lang="en-US" sz="1300" dirty="0"/>
+          </a:p>
+        </p:txBody>
+      </p:sp>
+      <p:sp>
+        <p:nvSpPr>
           <p:cNvPr id="9" name="Text 7"/>
           <p:cNvSpPr txBox="1"/>
           <p:nvPr/>
         </p:nvSpPr>
         <p:spPr>
           <a:xfrm>
-            <a:off x="868680" y="2834640"/>
-            <a:ext cx="1325880" cy="457200"/>
-          </a:xfrm>
-          <a:prstGeom prst="rect">
-            <a:avLst/>
-          </a:prstGeom>
-          <a:noFill/>
-          <a:ln/>
-        </p:spPr>
-        <p:txBody>
-          <a:bodyPr wrap="square" lIns="0" tIns="0" rIns="0" bIns="0" rtlCol="0" anchor="ctr"/>
-          <a:lstStyle/>
-          <a:p>
-            <a:pPr algn="l" indent="0" marL="0">
-              <a:buNone/>
-            </a:pPr>
-            <a:r>
-              <a:rPr lang="en-US" sz="1150" b="1" dirty="0">
-                <a:solidFill>
-                  <a:srgbClr val="1F2326"/>
-                </a:solidFill>
-                <a:latin typeface="Calibri" pitchFamily="34" charset="0"/>
-                <a:ea typeface="Calibri" pitchFamily="34" charset="-122"/>
-                <a:cs typeface="Calibri" pitchFamily="34" charset="-120"/>
-              </a:rPr>
-              <a:t>0 a 10</a:t>
+            <a:off x="914400" y="3383280"/>
+            <a:ext cx="2971800" cy="676656"/>
+          </a:xfrm>
+          <a:prstGeom prst="rect">
+            <a:avLst/>
+          </a:prstGeom>
+          <a:noFill/>
+          <a:ln/>
+        </p:spPr>
+        <p:txBody>
+          <a:bodyPr wrap="square" lIns="0" tIns="0" rIns="0" bIns="0" rtlCol="0" anchor="t"/>
+          <a:lstStyle/>
+          <a:p>
+            <a:pPr algn="l" indent="0" marL="0">
+              <a:buNone/>
+            </a:pPr>
+            <a:r>
+              <a:rPr lang="en-US" sz="1150" dirty="0">
+                <a:solidFill>
+                  <a:srgbClr val="33393D"/>
+                </a:solidFill>
+                <a:latin typeface="Calibri" pitchFamily="34" charset="0"/>
+                <a:ea typeface="Calibri" pitchFamily="34" charset="-122"/>
+                <a:cs typeface="Calibri" pitchFamily="34" charset="-120"/>
+              </a:rPr>
+              <a:t>El orden se sortea al empezar la Parte B.</a:t>
             </a:r>
             <a:endParaRPr lang="en-US" sz="1150" dirty="0"/>
           </a:p>
@@ -10622,96 +11343,18 @@
       </p:sp>
       <p:sp>
         <p:nvSpPr>
-          <p:cNvPr id="10" name="Text 8"/>
-          <p:cNvSpPr txBox="1"/>
-          <p:nvPr/>
-        </p:nvSpPr>
-        <p:spPr>
-          <a:xfrm>
-            <a:off x="2331720" y="2834640"/>
-            <a:ext cx="6537960" cy="457200"/>
-          </a:xfrm>
-          <a:prstGeom prst="rect">
-            <a:avLst/>
-          </a:prstGeom>
-          <a:noFill/>
-          <a:ln/>
-        </p:spPr>
-        <p:txBody>
-          <a:bodyPr wrap="square" lIns="0" tIns="0" rIns="0" bIns="0" rtlCol="0" anchor="ctr"/>
-          <a:lstStyle/>
-          <a:p>
-            <a:pPr algn="l" indent="0" marL="0">
-              <a:buNone/>
-            </a:pPr>
-            <a:r>
-              <a:rPr lang="en-US" sz="1150" dirty="0">
-                <a:solidFill>
-                  <a:srgbClr val="33393D"/>
-                </a:solidFill>
-                <a:latin typeface="Calibri" pitchFamily="34" charset="0"/>
-                <a:ea typeface="Calibri" pitchFamily="34" charset="-122"/>
-                <a:cs typeface="Calibri" pitchFamily="34" charset="-120"/>
-              </a:rPr>
-              <a:t>La carpeta e index.html con toda la estructura y los textos</a:t>
-            </a:r>
-            <a:endParaRPr lang="en-US" sz="1150" dirty="0"/>
-          </a:p>
-        </p:txBody>
-      </p:sp>
-      <p:sp>
-        <p:nvSpPr>
-          <p:cNvPr id="11" name="Text 9"/>
-          <p:cNvSpPr txBox="1"/>
-          <p:nvPr/>
-        </p:nvSpPr>
-        <p:spPr>
-          <a:xfrm>
-            <a:off x="9006840" y="2834640"/>
-            <a:ext cx="2651760" cy="457200"/>
-          </a:xfrm>
-          <a:prstGeom prst="rect">
-            <a:avLst/>
-          </a:prstGeom>
-          <a:noFill/>
-          <a:ln/>
-        </p:spPr>
-        <p:txBody>
-          <a:bodyPr wrap="square" lIns="0" tIns="0" rIns="0" bIns="0" rtlCol="0" anchor="ctr"/>
-          <a:lstStyle/>
-          <a:p>
-            <a:pPr algn="l" indent="0" marL="0">
-              <a:buNone/>
-            </a:pPr>
-            <a:r>
-              <a:rPr lang="en-US" sz="1150" dirty="0">
-                <a:solidFill>
-                  <a:srgbClr val="33393D"/>
-                </a:solidFill>
-                <a:latin typeface="Calibri" pitchFamily="34" charset="0"/>
-                <a:ea typeface="Calibri" pitchFamily="34" charset="-122"/>
-                <a:cs typeface="Calibri" pitchFamily="34" charset="-120"/>
-              </a:rPr>
-              <a:t>Estructura</a:t>
-            </a:r>
-            <a:endParaRPr lang="en-US" sz="1150" dirty="0"/>
-          </a:p>
-        </p:txBody>
-      </p:sp>
-      <p:sp>
-        <p:nvSpPr>
-          <p:cNvPr id="12" name="Shape 10"/>
+          <p:cNvPr id="10" name="Shape 8"/>
           <p:cNvSpPr/>
           <p:nvPr/>
         </p:nvSpPr>
         <p:spPr>
           <a:xfrm>
-            <a:off x="640080" y="3355848"/>
-            <a:ext cx="10927080" cy="457200"/>
+            <a:off x="4343400" y="2615184"/>
+            <a:ext cx="3520440" cy="1572768"/>
           </a:xfrm>
           <a:prstGeom prst="roundRect">
             <a:avLst>
-              <a:gd name="adj" fmla="val 20000"/>
+              <a:gd name="adj" fmla="val 5814"/>
             </a:avLst>
           </a:prstGeom>
           <a:solidFill>
@@ -10727,30 +11370,94 @@
       </p:sp>
       <p:sp>
         <p:nvSpPr>
+          <p:cNvPr id="11" name="Shape 9"/>
+          <p:cNvSpPr/>
+          <p:nvPr/>
+        </p:nvSpPr>
+        <p:spPr>
+          <a:xfrm>
+            <a:off x="4590288" y="2843784"/>
+            <a:ext cx="402336" cy="402336"/>
+          </a:xfrm>
+          <a:prstGeom prst="ellipse">
+            <a:avLst/>
+          </a:prstGeom>
+          <a:solidFill>
+            <a:srgbClr val="177E89"/>
+          </a:solidFill>
+          <a:ln w="12700">
+            <a:solidFill>
+              <a:srgbClr val="177E89"/>
+            </a:solidFill>
+            <a:prstDash val="solid"/>
+          </a:ln>
+        </p:spPr>
+      </p:sp>
+      <p:sp>
+        <p:nvSpPr>
+          <p:cNvPr id="12" name="Text 10"/>
+          <p:cNvSpPr txBox="1"/>
+          <p:nvPr/>
+        </p:nvSpPr>
+        <p:spPr>
+          <a:xfrm>
+            <a:off x="4590288" y="2843784"/>
+            <a:ext cx="402336" cy="402336"/>
+          </a:xfrm>
+          <a:prstGeom prst="rect">
+            <a:avLst/>
+          </a:prstGeom>
+          <a:noFill/>
+          <a:ln/>
+        </p:spPr>
+        <p:txBody>
+          <a:bodyPr wrap="square" lIns="0" tIns="0" rIns="0" bIns="0" rtlCol="0" anchor="ctr"/>
+          <a:lstStyle/>
+          <a:p>
+            <a:pPr algn="ctr" indent="0" marL="0">
+              <a:buNone/>
+            </a:pPr>
+            <a:r>
+              <a:rPr lang="en-US" sz="1200" b="1" dirty="0">
+                <a:solidFill>
+                  <a:srgbClr val="FFFFFF"/>
+                </a:solidFill>
+                <a:latin typeface="Calibri" pitchFamily="34" charset="0"/>
+                <a:ea typeface="Calibri" pitchFamily="34" charset="-122"/>
+                <a:cs typeface="Calibri" pitchFamily="34" charset="-120"/>
+              </a:rPr>
+              <a:t>2</a:t>
+            </a:r>
+            <a:endParaRPr lang="en-US" sz="1200" dirty="0"/>
+          </a:p>
+        </p:txBody>
+      </p:sp>
+      <p:sp>
+        <p:nvSpPr>
           <p:cNvPr id="13" name="Text 11"/>
           <p:cNvSpPr txBox="1"/>
           <p:nvPr/>
         </p:nvSpPr>
         <p:spPr>
           <a:xfrm>
-            <a:off x="868680" y="3355848"/>
-            <a:ext cx="1325880" cy="457200"/>
-          </a:xfrm>
-          <a:prstGeom prst="rect">
-            <a:avLst/>
-          </a:prstGeom>
-          <a:noFill/>
-          <a:ln/>
-        </p:spPr>
-        <p:txBody>
-          <a:bodyPr wrap="square" lIns="0" tIns="0" rIns="0" bIns="0" rtlCol="0" anchor="ctr"/>
-          <a:lstStyle/>
-          <a:p>
-            <a:pPr algn="l" indent="0" marL="0">
-              <a:buNone/>
-            </a:pPr>
-            <a:r>
-              <a:rPr lang="en-US" sz="1150" b="1" dirty="0">
+            <a:off x="5148072" y="2843784"/>
+            <a:ext cx="2560320" cy="402336"/>
+          </a:xfrm>
+          <a:prstGeom prst="rect">
+            <a:avLst/>
+          </a:prstGeom>
+          <a:noFill/>
+          <a:ln/>
+        </p:spPr>
+        <p:txBody>
+          <a:bodyPr wrap="square" lIns="0" tIns="0" rIns="0" bIns="0" rtlCol="0" anchor="ctr"/>
+          <a:lstStyle/>
+          <a:p>
+            <a:pPr algn="l" indent="0" marL="0">
+              <a:buNone/>
+            </a:pPr>
+            <a:r>
+              <a:rPr lang="en-US" sz="1300" b="1" dirty="0">
                 <a:solidFill>
                   <a:srgbClr val="1F2326"/>
                 </a:solidFill>
@@ -10758,7 +11465,46 @@
                 <a:ea typeface="Calibri" pitchFamily="34" charset="-122"/>
                 <a:cs typeface="Calibri" pitchFamily="34" charset="-120"/>
               </a:rPr>
-              <a:t>10 a 40</a:t>
+              <a:t>5 + 2 minutos</a:t>
+            </a:r>
+            <a:endParaRPr lang="en-US" sz="1300" dirty="0"/>
+          </a:p>
+        </p:txBody>
+      </p:sp>
+      <p:sp>
+        <p:nvSpPr>
+          <p:cNvPr id="14" name="Text 12"/>
+          <p:cNvSpPr txBox="1"/>
+          <p:nvPr/>
+        </p:nvSpPr>
+        <p:spPr>
+          <a:xfrm>
+            <a:off x="4617720" y="3383280"/>
+            <a:ext cx="2971800" cy="676656"/>
+          </a:xfrm>
+          <a:prstGeom prst="rect">
+            <a:avLst/>
+          </a:prstGeom>
+          <a:noFill/>
+          <a:ln/>
+        </p:spPr>
+        <p:txBody>
+          <a:bodyPr wrap="square" lIns="0" tIns="0" rIns="0" bIns="0" rtlCol="0" anchor="t"/>
+          <a:lstStyle/>
+          <a:p>
+            <a:pPr algn="l" indent="0" marL="0">
+              <a:buNone/>
+            </a:pPr>
+            <a:r>
+              <a:rPr lang="en-US" sz="1150" dirty="0">
+                <a:solidFill>
+                  <a:srgbClr val="33393D"/>
+                </a:solidFill>
+                <a:latin typeface="Calibri" pitchFamily="34" charset="0"/>
+                <a:ea typeface="Calibri" pitchFamily="34" charset="-122"/>
+                <a:cs typeface="Calibri" pitchFamily="34" charset="-120"/>
+              </a:rPr>
+              <a:t>Cinco para presentar y dos para las preguntas. El tiempo se cuenta en pantalla.</a:t>
             </a:r>
             <a:endParaRPr lang="en-US" sz="1150" dirty="0"/>
           </a:p>
@@ -10766,96 +11512,18 @@
       </p:sp>
       <p:sp>
         <p:nvSpPr>
-          <p:cNvPr id="14" name="Text 12"/>
-          <p:cNvSpPr txBox="1"/>
-          <p:nvPr/>
-        </p:nvSpPr>
-        <p:spPr>
-          <a:xfrm>
-            <a:off x="2331720" y="3355848"/>
-            <a:ext cx="6537960" cy="457200"/>
-          </a:xfrm>
-          <a:prstGeom prst="rect">
-            <a:avLst/>
-          </a:prstGeom>
-          <a:noFill/>
-          <a:ln/>
-        </p:spPr>
-        <p:txBody>
-          <a:bodyPr wrap="square" lIns="0" tIns="0" rIns="0" bIns="0" rtlCol="0" anchor="ctr"/>
-          <a:lstStyle/>
-          <a:p>
-            <a:pPr algn="l" indent="0" marL="0">
-              <a:buNone/>
-            </a:pPr>
-            <a:r>
-              <a:rPr lang="en-US" sz="1150" dirty="0">
-                <a:solidFill>
-                  <a:srgbClr val="33393D"/>
-                </a:solidFill>
-                <a:latin typeface="Calibri" pitchFamily="34" charset="0"/>
-                <a:ea typeface="Calibri" pitchFamily="34" charset="-122"/>
-                <a:cs typeface="Calibri" pitchFamily="34" charset="-120"/>
-              </a:rPr>
-              <a:t>Variables, reset, cabecera, presentación, botón y charlas</a:t>
-            </a:r>
-            <a:endParaRPr lang="en-US" sz="1150" dirty="0"/>
-          </a:p>
-        </p:txBody>
-      </p:sp>
-      <p:sp>
-        <p:nvSpPr>
-          <p:cNvPr id="15" name="Text 13"/>
-          <p:cNvSpPr txBox="1"/>
-          <p:nvPr/>
-        </p:nvSpPr>
-        <p:spPr>
-          <a:xfrm>
-            <a:off x="9006840" y="3355848"/>
-            <a:ext cx="2651760" cy="457200"/>
-          </a:xfrm>
-          <a:prstGeom prst="rect">
-            <a:avLst/>
-          </a:prstGeom>
-          <a:noFill/>
-          <a:ln/>
-        </p:spPr>
-        <p:txBody>
-          <a:bodyPr wrap="square" lIns="0" tIns="0" rIns="0" bIns="0" rtlCol="0" anchor="ctr"/>
-          <a:lstStyle/>
-          <a:p>
-            <a:pPr algn="l" indent="0" marL="0">
-              <a:buNone/>
-            </a:pPr>
-            <a:r>
-              <a:rPr lang="en-US" sz="1150" dirty="0">
-                <a:solidFill>
-                  <a:srgbClr val="33393D"/>
-                </a:solidFill>
-                <a:latin typeface="Calibri" pitchFamily="34" charset="0"/>
-                <a:ea typeface="Calibri" pitchFamily="34" charset="-122"/>
-                <a:cs typeface="Calibri" pitchFamily="34" charset="-120"/>
-              </a:rPr>
-              <a:t>Estilos y maquetación</a:t>
-            </a:r>
-            <a:endParaRPr lang="en-US" sz="1150" dirty="0"/>
-          </a:p>
-        </p:txBody>
-      </p:sp>
-      <p:sp>
-        <p:nvSpPr>
-          <p:cNvPr id="16" name="Shape 14"/>
+          <p:cNvPr id="15" name="Shape 13"/>
           <p:cNvSpPr/>
           <p:nvPr/>
         </p:nvSpPr>
         <p:spPr>
           <a:xfrm>
-            <a:off x="640080" y="3877056"/>
-            <a:ext cx="10927080" cy="457200"/>
+            <a:off x="8046720" y="2615184"/>
+            <a:ext cx="3520440" cy="1572768"/>
           </a:xfrm>
           <a:prstGeom prst="roundRect">
             <a:avLst>
-              <a:gd name="adj" fmla="val 20000"/>
+              <a:gd name="adj" fmla="val 5814"/>
             </a:avLst>
           </a:prstGeom>
           <a:solidFill>
@@ -10871,30 +11539,94 @@
       </p:sp>
       <p:sp>
         <p:nvSpPr>
+          <p:cNvPr id="16" name="Shape 14"/>
+          <p:cNvSpPr/>
+          <p:nvPr/>
+        </p:nvSpPr>
+        <p:spPr>
+          <a:xfrm>
+            <a:off x="8293608" y="2843784"/>
+            <a:ext cx="402336" cy="402336"/>
+          </a:xfrm>
+          <a:prstGeom prst="ellipse">
+            <a:avLst/>
+          </a:prstGeom>
+          <a:solidFill>
+            <a:srgbClr val="177E89"/>
+          </a:solidFill>
+          <a:ln w="12700">
+            <a:solidFill>
+              <a:srgbClr val="177E89"/>
+            </a:solidFill>
+            <a:prstDash val="solid"/>
+          </a:ln>
+        </p:spPr>
+      </p:sp>
+      <p:sp>
+        <p:nvSpPr>
           <p:cNvPr id="17" name="Text 15"/>
           <p:cNvSpPr txBox="1"/>
           <p:nvPr/>
         </p:nvSpPr>
         <p:spPr>
           <a:xfrm>
-            <a:off x="868680" y="3877056"/>
-            <a:ext cx="1325880" cy="457200"/>
-          </a:xfrm>
-          <a:prstGeom prst="rect">
-            <a:avLst/>
-          </a:prstGeom>
-          <a:noFill/>
-          <a:ln/>
-        </p:spPr>
-        <p:txBody>
-          <a:bodyPr wrap="square" lIns="0" tIns="0" rIns="0" bIns="0" rtlCol="0" anchor="ctr"/>
-          <a:lstStyle/>
-          <a:p>
-            <a:pPr algn="l" indent="0" marL="0">
-              <a:buNone/>
-            </a:pPr>
-            <a:r>
-              <a:rPr lang="en-US" sz="1150" b="1" dirty="0">
+            <a:off x="8293608" y="2843784"/>
+            <a:ext cx="402336" cy="402336"/>
+          </a:xfrm>
+          <a:prstGeom prst="rect">
+            <a:avLst/>
+          </a:prstGeom>
+          <a:noFill/>
+          <a:ln/>
+        </p:spPr>
+        <p:txBody>
+          <a:bodyPr wrap="square" lIns="0" tIns="0" rIns="0" bIns="0" rtlCol="0" anchor="ctr"/>
+          <a:lstStyle/>
+          <a:p>
+            <a:pPr algn="ctr" indent="0" marL="0">
+              <a:buNone/>
+            </a:pPr>
+            <a:r>
+              <a:rPr lang="en-US" sz="1200" b="1" dirty="0">
+                <a:solidFill>
+                  <a:srgbClr val="FFFFFF"/>
+                </a:solidFill>
+                <a:latin typeface="Calibri" pitchFamily="34" charset="0"/>
+                <a:ea typeface="Calibri" pitchFamily="34" charset="-122"/>
+                <a:cs typeface="Calibri" pitchFamily="34" charset="-120"/>
+              </a:rPr>
+              <a:t>3</a:t>
+            </a:r>
+            <a:endParaRPr lang="en-US" sz="1200" dirty="0"/>
+          </a:p>
+        </p:txBody>
+      </p:sp>
+      <p:sp>
+        <p:nvSpPr>
+          <p:cNvPr id="18" name="Text 16"/>
+          <p:cNvSpPr txBox="1"/>
+          <p:nvPr/>
+        </p:nvSpPr>
+        <p:spPr>
+          <a:xfrm>
+            <a:off x="8851392" y="2843784"/>
+            <a:ext cx="2560320" cy="402336"/>
+          </a:xfrm>
+          <a:prstGeom prst="rect">
+            <a:avLst/>
+          </a:prstGeom>
+          <a:noFill/>
+          <a:ln/>
+        </p:spPr>
+        <p:txBody>
+          <a:bodyPr wrap="square" lIns="0" tIns="0" rIns="0" bIns="0" rtlCol="0" anchor="ctr"/>
+          <a:lstStyle/>
+          <a:p>
+            <a:pPr algn="l" indent="0" marL="0">
+              <a:buNone/>
+            </a:pPr>
+            <a:r>
+              <a:rPr lang="en-US" sz="1300" b="1" dirty="0">
                 <a:solidFill>
                   <a:srgbClr val="1F2326"/>
                 </a:solidFill>
@@ -10902,31 +11634,31 @@
                 <a:ea typeface="Calibri" pitchFamily="34" charset="-122"/>
                 <a:cs typeface="Calibri" pitchFamily="34" charset="-120"/>
               </a:rPr>
-              <a:t>40 a 55</a:t>
-            </a:r>
-            <a:endParaRPr lang="en-US" sz="1150" dirty="0"/>
-          </a:p>
-        </p:txBody>
-      </p:sp>
-      <p:sp>
-        <p:nvSpPr>
-          <p:cNvPr id="18" name="Text 16"/>
-          <p:cNvSpPr txBox="1"/>
-          <p:nvPr/>
-        </p:nvSpPr>
-        <p:spPr>
-          <a:xfrm>
-            <a:off x="2331720" y="3877056"/>
-            <a:ext cx="6537960" cy="457200"/>
-          </a:xfrm>
-          <a:prstGeom prst="rect">
-            <a:avLst/>
-          </a:prstGeom>
-          <a:noFill/>
-          <a:ln/>
-        </p:spPr>
-        <p:txBody>
-          <a:bodyPr wrap="square" lIns="0" tIns="0" rIns="0" bIns="0" rtlCol="0" anchor="ctr"/>
+              <a:t>Prepárate</a:t>
+            </a:r>
+            <a:endParaRPr lang="en-US" sz="1300" dirty="0"/>
+          </a:p>
+        </p:txBody>
+      </p:sp>
+      <p:sp>
+        <p:nvSpPr>
+          <p:cNvPr id="19" name="Text 17"/>
+          <p:cNvSpPr txBox="1"/>
+          <p:nvPr/>
+        </p:nvSpPr>
+        <p:spPr>
+          <a:xfrm>
+            <a:off x="8321040" y="3383280"/>
+            <a:ext cx="2971800" cy="676656"/>
+          </a:xfrm>
+          <a:prstGeom prst="rect">
+            <a:avLst/>
+          </a:prstGeom>
+          <a:noFill/>
+          <a:ln/>
+        </p:spPr>
+        <p:txBody>
+          <a:bodyPr wrap="square" lIns="0" tIns="0" rIns="0" bIns="0" rtlCol="0" anchor="t"/>
           <a:lstStyle/>
           <a:p>
             <a:pPr algn="l" indent="0" marL="0">
@@ -10941,46 +11673,7 @@
                 <a:ea typeface="Calibri" pitchFamily="34" charset="-122"/>
                 <a:cs typeface="Calibri" pitchFamily="34" charset="-120"/>
               </a:rPr>
-              <a:t>El formulario y el pie</a:t>
-            </a:r>
-            <a:endParaRPr lang="en-US" sz="1150" dirty="0"/>
-          </a:p>
-        </p:txBody>
-      </p:sp>
-      <p:sp>
-        <p:nvSpPr>
-          <p:cNvPr id="19" name="Text 17"/>
-          <p:cNvSpPr txBox="1"/>
-          <p:nvPr/>
-        </p:nvSpPr>
-        <p:spPr>
-          <a:xfrm>
-            <a:off x="9006840" y="3877056"/>
-            <a:ext cx="2651760" cy="457200"/>
-          </a:xfrm>
-          <a:prstGeom prst="rect">
-            <a:avLst/>
-          </a:prstGeom>
-          <a:noFill/>
-          <a:ln/>
-        </p:spPr>
-        <p:txBody>
-          <a:bodyPr wrap="square" lIns="0" tIns="0" rIns="0" bIns="0" rtlCol="0" anchor="ctr"/>
-          <a:lstStyle/>
-          <a:p>
-            <a:pPr algn="l" indent="0" marL="0">
-              <a:buNone/>
-            </a:pPr>
-            <a:r>
-              <a:rPr lang="en-US" sz="1150" dirty="0">
-                <a:solidFill>
-                  <a:srgbClr val="33393D"/>
-                </a:solidFill>
-                <a:latin typeface="Calibri" pitchFamily="34" charset="0"/>
-                <a:ea typeface="Calibri" pitchFamily="34" charset="-122"/>
-                <a:cs typeface="Calibri" pitchFamily="34" charset="-120"/>
-              </a:rPr>
-              <a:t>Formulario</a:t>
+              <a:t>Cuando presenta el compañero anterior, abre tus pestañas: sitio, Figma, bitácora y Lighthouse.</a:t>
             </a:r>
             <a:endParaRPr lang="en-US" sz="1150" dirty="0"/>
           </a:p>
@@ -10994,12 +11687,12 @@
         </p:nvSpPr>
         <p:spPr>
           <a:xfrm>
-            <a:off x="640080" y="4398264"/>
-            <a:ext cx="10927080" cy="457200"/>
+            <a:off x="640080" y="4352544"/>
+            <a:ext cx="3520440" cy="1572768"/>
           </a:xfrm>
           <a:prstGeom prst="roundRect">
             <a:avLst>
-              <a:gd name="adj" fmla="val 20000"/>
+              <a:gd name="adj" fmla="val 5814"/>
             </a:avLst>
           </a:prstGeom>
           <a:solidFill>
@@ -11015,30 +11708,94 @@
       </p:sp>
       <p:sp>
         <p:nvSpPr>
-          <p:cNvPr id="21" name="Text 19"/>
-          <p:cNvSpPr txBox="1"/>
-          <p:nvPr/>
-        </p:nvSpPr>
-        <p:spPr>
-          <a:xfrm>
-            <a:off x="868680" y="4398264"/>
-            <a:ext cx="1325880" cy="457200"/>
-          </a:xfrm>
-          <a:prstGeom prst="rect">
-            <a:avLst/>
-          </a:prstGeom>
-          <a:noFill/>
-          <a:ln/>
-        </p:spPr>
-        <p:txBody>
-          <a:bodyPr wrap="square" lIns="0" tIns="0" rIns="0" bIns="0" rtlCol="0" anchor="ctr"/>
-          <a:lstStyle/>
-          <a:p>
-            <a:pPr algn="l" indent="0" marL="0">
-              <a:buNone/>
-            </a:pPr>
-            <a:r>
-              <a:rPr lang="en-US" sz="1150" b="1" dirty="0">
+          <p:cNvPr id="21" name="Shape 19"/>
+          <p:cNvSpPr/>
+          <p:nvPr/>
+        </p:nvSpPr>
+        <p:spPr>
+          <a:xfrm>
+            <a:off x="886968" y="4581144"/>
+            <a:ext cx="402336" cy="402336"/>
+          </a:xfrm>
+          <a:prstGeom prst="ellipse">
+            <a:avLst/>
+          </a:prstGeom>
+          <a:solidFill>
+            <a:srgbClr val="177E89"/>
+          </a:solidFill>
+          <a:ln w="12700">
+            <a:solidFill>
+              <a:srgbClr val="177E89"/>
+            </a:solidFill>
+            <a:prstDash val="solid"/>
+          </a:ln>
+        </p:spPr>
+      </p:sp>
+      <p:sp>
+        <p:nvSpPr>
+          <p:cNvPr id="22" name="Text 20"/>
+          <p:cNvSpPr txBox="1"/>
+          <p:nvPr/>
+        </p:nvSpPr>
+        <p:spPr>
+          <a:xfrm>
+            <a:off x="886968" y="4581144"/>
+            <a:ext cx="402336" cy="402336"/>
+          </a:xfrm>
+          <a:prstGeom prst="rect">
+            <a:avLst/>
+          </a:prstGeom>
+          <a:noFill/>
+          <a:ln/>
+        </p:spPr>
+        <p:txBody>
+          <a:bodyPr wrap="square" lIns="0" tIns="0" rIns="0" bIns="0" rtlCol="0" anchor="ctr"/>
+          <a:lstStyle/>
+          <a:p>
+            <a:pPr algn="ctr" indent="0" marL="0">
+              <a:buNone/>
+            </a:pPr>
+            <a:r>
+              <a:rPr lang="en-US" sz="1200" b="1" dirty="0">
+                <a:solidFill>
+                  <a:srgbClr val="FFFFFF"/>
+                </a:solidFill>
+                <a:latin typeface="Calibri" pitchFamily="34" charset="0"/>
+                <a:ea typeface="Calibri" pitchFamily="34" charset="-122"/>
+                <a:cs typeface="Calibri" pitchFamily="34" charset="-120"/>
+              </a:rPr>
+              <a:t>4</a:t>
+            </a:r>
+            <a:endParaRPr lang="en-US" sz="1200" dirty="0"/>
+          </a:p>
+        </p:txBody>
+      </p:sp>
+      <p:sp>
+        <p:nvSpPr>
+          <p:cNvPr id="23" name="Text 21"/>
+          <p:cNvSpPr txBox="1"/>
+          <p:nvPr/>
+        </p:nvSpPr>
+        <p:spPr>
+          <a:xfrm>
+            <a:off x="1444752" y="4581144"/>
+            <a:ext cx="2560320" cy="402336"/>
+          </a:xfrm>
+          <a:prstGeom prst="rect">
+            <a:avLst/>
+          </a:prstGeom>
+          <a:noFill/>
+          <a:ln/>
+        </p:spPr>
+        <p:txBody>
+          <a:bodyPr wrap="square" lIns="0" tIns="0" rIns="0" bIns="0" rtlCol="0" anchor="ctr"/>
+          <a:lstStyle/>
+          <a:p>
+            <a:pPr algn="l" indent="0" marL="0">
+              <a:buNone/>
+            </a:pPr>
+            <a:r>
+              <a:rPr lang="en-US" sz="1300" b="1" dirty="0">
                 <a:solidFill>
                   <a:srgbClr val="1F2326"/>
                 </a:solidFill>
@@ -11046,7 +11803,46 @@
                 <a:ea typeface="Calibri" pitchFamily="34" charset="-122"/>
                 <a:cs typeface="Calibri" pitchFamily="34" charset="-120"/>
               </a:rPr>
-              <a:t>55 a 65</a:t>
+              <a:t>Preguntas</a:t>
+            </a:r>
+            <a:endParaRPr lang="en-US" sz="1300" dirty="0"/>
+          </a:p>
+        </p:txBody>
+      </p:sp>
+      <p:sp>
+        <p:nvSpPr>
+          <p:cNvPr id="24" name="Text 22"/>
+          <p:cNvSpPr txBox="1"/>
+          <p:nvPr/>
+        </p:nvSpPr>
+        <p:spPr>
+          <a:xfrm>
+            <a:off x="914400" y="5120640"/>
+            <a:ext cx="2971800" cy="676656"/>
+          </a:xfrm>
+          <a:prstGeom prst="rect">
+            <a:avLst/>
+          </a:prstGeom>
+          <a:noFill/>
+          <a:ln/>
+        </p:spPr>
+        <p:txBody>
+          <a:bodyPr wrap="square" lIns="0" tIns="0" rIns="0" bIns="0" rtlCol="0" anchor="t"/>
+          <a:lstStyle/>
+          <a:p>
+            <a:pPr algn="l" indent="0" marL="0">
+              <a:buNone/>
+            </a:pPr>
+            <a:r>
+              <a:rPr lang="en-US" sz="1150" dirty="0">
+                <a:solidFill>
+                  <a:srgbClr val="33393D"/>
+                </a:solidFill>
+                <a:latin typeface="Calibri" pitchFamily="34" charset="0"/>
+                <a:ea typeface="Calibri" pitchFamily="34" charset="-122"/>
+                <a:cs typeface="Calibri" pitchFamily="34" charset="-120"/>
+              </a:rPr>
+              <a:t>Te pueden pedir que abras tu CSS o tu HTML y expliques una regla o una etiqueta.</a:t>
             </a:r>
             <a:endParaRPr lang="en-US" sz="1150" dirty="0"/>
           </a:p>
@@ -11054,96 +11850,18 @@
       </p:sp>
       <p:sp>
         <p:nvSpPr>
-          <p:cNvPr id="22" name="Text 20"/>
-          <p:cNvSpPr txBox="1"/>
-          <p:nvPr/>
-        </p:nvSpPr>
-        <p:spPr>
-          <a:xfrm>
-            <a:off x="2331720" y="4398264"/>
-            <a:ext cx="6537960" cy="457200"/>
-          </a:xfrm>
-          <a:prstGeom prst="rect">
-            <a:avLst/>
-          </a:prstGeom>
-          <a:noFill/>
-          <a:ln/>
-        </p:spPr>
-        <p:txBody>
-          <a:bodyPr wrap="square" lIns="0" tIns="0" rIns="0" bIns="0" rtlCol="0" anchor="ctr"/>
-          <a:lstStyle/>
-          <a:p>
-            <a:pPr algn="l" indent="0" marL="0">
-              <a:buNone/>
-            </a:pPr>
-            <a:r>
-              <a:rPr lang="en-US" sz="1150" dirty="0">
-                <a:solidFill>
-                  <a:srgbClr val="33393D"/>
-                </a:solidFill>
-                <a:latin typeface="Calibri" pitchFamily="34" charset="0"/>
-                <a:ea typeface="Calibri" pitchFamily="34" charset="-122"/>
-                <a:cs typeface="Calibri" pitchFamily="34" charset="-120"/>
-              </a:rPr>
-              <a:t>La media query del celular; prueba a 390px con F12</a:t>
-            </a:r>
-            <a:endParaRPr lang="en-US" sz="1150" dirty="0"/>
-          </a:p>
-        </p:txBody>
-      </p:sp>
-      <p:sp>
-        <p:nvSpPr>
-          <p:cNvPr id="23" name="Text 21"/>
-          <p:cNvSpPr txBox="1"/>
-          <p:nvPr/>
-        </p:nvSpPr>
-        <p:spPr>
-          <a:xfrm>
-            <a:off x="9006840" y="4398264"/>
-            <a:ext cx="2651760" cy="457200"/>
-          </a:xfrm>
-          <a:prstGeom prst="rect">
-            <a:avLst/>
-          </a:prstGeom>
-          <a:noFill/>
-          <a:ln/>
-        </p:spPr>
-        <p:txBody>
-          <a:bodyPr wrap="square" lIns="0" tIns="0" rIns="0" bIns="0" rtlCol="0" anchor="ctr"/>
-          <a:lstStyle/>
-          <a:p>
-            <a:pPr algn="l" indent="0" marL="0">
-              <a:buNone/>
-            </a:pPr>
-            <a:r>
-              <a:rPr lang="en-US" sz="1150" dirty="0">
-                <a:solidFill>
-                  <a:srgbClr val="33393D"/>
-                </a:solidFill>
-                <a:latin typeface="Calibri" pitchFamily="34" charset="0"/>
-                <a:ea typeface="Calibri" pitchFamily="34" charset="-122"/>
-                <a:cs typeface="Calibri" pitchFamily="34" charset="-120"/>
-              </a:rPr>
-              <a:t>Adaptable</a:t>
-            </a:r>
-            <a:endParaRPr lang="en-US" sz="1150" dirty="0"/>
-          </a:p>
-        </p:txBody>
-      </p:sp>
-      <p:sp>
-        <p:nvSpPr>
-          <p:cNvPr id="24" name="Shape 22"/>
+          <p:cNvPr id="25" name="Shape 23"/>
           <p:cNvSpPr/>
           <p:nvPr/>
         </p:nvSpPr>
         <p:spPr>
           <a:xfrm>
-            <a:off x="640080" y="4919472"/>
-            <a:ext cx="10927080" cy="457200"/>
+            <a:off x="4343400" y="4352544"/>
+            <a:ext cx="3520440" cy="1572768"/>
           </a:xfrm>
           <a:prstGeom prst="roundRect">
             <a:avLst>
-              <a:gd name="adj" fmla="val 20000"/>
+              <a:gd name="adj" fmla="val 5814"/>
             </a:avLst>
           </a:prstGeom>
           <a:solidFill>
@@ -11159,30 +11877,94 @@
       </p:sp>
       <p:sp>
         <p:nvSpPr>
-          <p:cNvPr id="25" name="Text 23"/>
-          <p:cNvSpPr txBox="1"/>
-          <p:nvPr/>
-        </p:nvSpPr>
-        <p:spPr>
-          <a:xfrm>
-            <a:off x="868680" y="4919472"/>
-            <a:ext cx="1325880" cy="457200"/>
-          </a:xfrm>
-          <a:prstGeom prst="rect">
-            <a:avLst/>
-          </a:prstGeom>
-          <a:noFill/>
-          <a:ln/>
-        </p:spPr>
-        <p:txBody>
-          <a:bodyPr wrap="square" lIns="0" tIns="0" rIns="0" bIns="0" rtlCol="0" anchor="ctr"/>
-          <a:lstStyle/>
-          <a:p>
-            <a:pPr algn="l" indent="0" marL="0">
-              <a:buNone/>
-            </a:pPr>
-            <a:r>
-              <a:rPr lang="en-US" sz="1150" b="1" dirty="0">
+          <p:cNvPr id="26" name="Shape 24"/>
+          <p:cNvSpPr/>
+          <p:nvPr/>
+        </p:nvSpPr>
+        <p:spPr>
+          <a:xfrm>
+            <a:off x="4590288" y="4581144"/>
+            <a:ext cx="402336" cy="402336"/>
+          </a:xfrm>
+          <a:prstGeom prst="ellipse">
+            <a:avLst/>
+          </a:prstGeom>
+          <a:solidFill>
+            <a:srgbClr val="177E89"/>
+          </a:solidFill>
+          <a:ln w="12700">
+            <a:solidFill>
+              <a:srgbClr val="177E89"/>
+            </a:solidFill>
+            <a:prstDash val="solid"/>
+          </a:ln>
+        </p:spPr>
+      </p:sp>
+      <p:sp>
+        <p:nvSpPr>
+          <p:cNvPr id="27" name="Text 25"/>
+          <p:cNvSpPr txBox="1"/>
+          <p:nvPr/>
+        </p:nvSpPr>
+        <p:spPr>
+          <a:xfrm>
+            <a:off x="4590288" y="4581144"/>
+            <a:ext cx="402336" cy="402336"/>
+          </a:xfrm>
+          <a:prstGeom prst="rect">
+            <a:avLst/>
+          </a:prstGeom>
+          <a:noFill/>
+          <a:ln/>
+        </p:spPr>
+        <p:txBody>
+          <a:bodyPr wrap="square" lIns="0" tIns="0" rIns="0" bIns="0" rtlCol="0" anchor="ctr"/>
+          <a:lstStyle/>
+          <a:p>
+            <a:pPr algn="ctr" indent="0" marL="0">
+              <a:buNone/>
+            </a:pPr>
+            <a:r>
+              <a:rPr lang="en-US" sz="1200" b="1" dirty="0">
+                <a:solidFill>
+                  <a:srgbClr val="FFFFFF"/>
+                </a:solidFill>
+                <a:latin typeface="Calibri" pitchFamily="34" charset="0"/>
+                <a:ea typeface="Calibri" pitchFamily="34" charset="-122"/>
+                <a:cs typeface="Calibri" pitchFamily="34" charset="-120"/>
+              </a:rPr>
+              <a:t>5</a:t>
+            </a:r>
+            <a:endParaRPr lang="en-US" sz="1200" dirty="0"/>
+          </a:p>
+        </p:txBody>
+      </p:sp>
+      <p:sp>
+        <p:nvSpPr>
+          <p:cNvPr id="28" name="Text 26"/>
+          <p:cNvSpPr txBox="1"/>
+          <p:nvPr/>
+        </p:nvSpPr>
+        <p:spPr>
+          <a:xfrm>
+            <a:off x="5148072" y="4581144"/>
+            <a:ext cx="2560320" cy="402336"/>
+          </a:xfrm>
+          <a:prstGeom prst="rect">
+            <a:avLst/>
+          </a:prstGeom>
+          <a:noFill/>
+          <a:ln/>
+        </p:spPr>
+        <p:txBody>
+          <a:bodyPr wrap="square" lIns="0" tIns="0" rIns="0" bIns="0" rtlCol="0" anchor="ctr"/>
+          <a:lstStyle/>
+          <a:p>
+            <a:pPr algn="l" indent="0" marL="0">
+              <a:buNone/>
+            </a:pPr>
+            <a:r>
+              <a:rPr lang="en-US" sz="1300" b="1" dirty="0">
                 <a:solidFill>
                   <a:srgbClr val="1F2326"/>
                 </a:solidFill>
@@ -11190,7 +11972,74 @@
                 <a:ea typeface="Calibri" pitchFamily="34" charset="-122"/>
                 <a:cs typeface="Calibri" pitchFamily="34" charset="-120"/>
               </a:rPr>
-              <a:t>65 a 75</a:t>
+              <a:t>Plan B</a:t>
+            </a:r>
+            <a:endParaRPr lang="en-US" sz="1300" dirty="0"/>
+          </a:p>
+        </p:txBody>
+      </p:sp>
+      <p:sp>
+        <p:nvSpPr>
+          <p:cNvPr id="29" name="Text 27"/>
+          <p:cNvSpPr txBox="1"/>
+          <p:nvPr/>
+        </p:nvSpPr>
+        <p:spPr>
+          <a:xfrm>
+            <a:off x="4617720" y="5120640"/>
+            <a:ext cx="2971800" cy="676656"/>
+          </a:xfrm>
+          <a:prstGeom prst="rect">
+            <a:avLst/>
+          </a:prstGeom>
+          <a:noFill/>
+          <a:ln/>
+        </p:spPr>
+        <p:txBody>
+          <a:bodyPr wrap="square" lIns="0" tIns="0" rIns="0" bIns="0" rtlCol="0" anchor="t"/>
+          <a:lstStyle/>
+          <a:p>
+            <a:pPr algn="l" indent="0" marL="0">
+              <a:buNone/>
+            </a:pPr>
+            <a:r>
+              <a:rPr lang="en-US" sz="1150" dirty="0">
+                <a:solidFill>
+                  <a:srgbClr val="33393D"/>
+                </a:solidFill>
+                <a:latin typeface="Calibri" pitchFamily="34" charset="0"/>
+                <a:ea typeface="Calibri" pitchFamily="34" charset="-122"/>
+                <a:cs typeface="Calibri" pitchFamily="34" charset="-120"/>
+              </a:rPr>
+              <a:t>Si se cae internet, presentas desde tu carpeta </a:t>
+            </a:r>
+            <a:pPr algn="l" indent="0" marL="0">
+              <a:buNone/>
+            </a:pPr>
+            <a:r>
+              <a:rPr lang="en-US" sz="1150" dirty="0">
+                <a:solidFill>
+                  <a:srgbClr val="1F2326"/>
+                </a:solidFill>
+                <a:latin typeface="Consolas" pitchFamily="34" charset="0"/>
+                <a:ea typeface="Consolas" pitchFamily="34" charset="-122"/>
+                <a:cs typeface="Consolas" pitchFamily="34" charset="-120"/>
+              </a:rPr>
+              <a:t>.zip</a:t>
+            </a:r>
+            <a:pPr algn="l" indent="0" marL="0">
+              <a:buNone/>
+            </a:pPr>
+            <a:r>
+              <a:rPr lang="en-US" sz="1150" dirty="0">
+                <a:solidFill>
+                  <a:srgbClr val="33393D"/>
+                </a:solidFill>
+                <a:latin typeface="Calibri" pitchFamily="34" charset="0"/>
+                <a:ea typeface="Calibri" pitchFamily="34" charset="-122"/>
+                <a:cs typeface="Calibri" pitchFamily="34" charset="-120"/>
+              </a:rPr>
+              <a:t> en tu computadora.</a:t>
             </a:r>
             <a:endParaRPr lang="en-US" sz="1150" dirty="0"/>
           </a:p>
@@ -11198,100 +12047,22 @@
       </p:sp>
       <p:sp>
         <p:nvSpPr>
-          <p:cNvPr id="26" name="Text 24"/>
-          <p:cNvSpPr txBox="1"/>
-          <p:nvPr/>
-        </p:nvSpPr>
-        <p:spPr>
-          <a:xfrm>
-            <a:off x="2331720" y="4919472"/>
-            <a:ext cx="6537960" cy="457200"/>
-          </a:xfrm>
-          <a:prstGeom prst="rect">
-            <a:avLst/>
-          </a:prstGeom>
-          <a:noFill/>
-          <a:ln/>
-        </p:spPr>
-        <p:txBody>
-          <a:bodyPr wrap="square" lIns="0" tIns="0" rIns="0" bIns="0" rtlCol="0" anchor="ctr"/>
-          <a:lstStyle/>
-          <a:p>
-            <a:pPr algn="l" indent="0" marL="0">
-              <a:buNone/>
-            </a:pPr>
-            <a:r>
-              <a:rPr lang="en-US" sz="1150" dirty="0">
-                <a:solidFill>
-                  <a:srgbClr val="33393D"/>
-                </a:solidFill>
-                <a:latin typeface="Calibri" pitchFamily="34" charset="0"/>
-                <a:ea typeface="Calibri" pitchFamily="34" charset="-122"/>
-                <a:cs typeface="Calibri" pitchFamily="34" charset="-120"/>
-              </a:rPr>
-              <a:t>Valida el HTML y el CSS en el W3C y corrige</a:t>
-            </a:r>
-            <a:endParaRPr lang="en-US" sz="1150" dirty="0"/>
-          </a:p>
-        </p:txBody>
-      </p:sp>
-      <p:sp>
-        <p:nvSpPr>
-          <p:cNvPr id="27" name="Text 25"/>
-          <p:cNvSpPr txBox="1"/>
-          <p:nvPr/>
-        </p:nvSpPr>
-        <p:spPr>
-          <a:xfrm>
-            <a:off x="9006840" y="4919472"/>
-            <a:ext cx="2651760" cy="457200"/>
-          </a:xfrm>
-          <a:prstGeom prst="rect">
-            <a:avLst/>
-          </a:prstGeom>
-          <a:noFill/>
-          <a:ln/>
-        </p:spPr>
-        <p:txBody>
-          <a:bodyPr wrap="square" lIns="0" tIns="0" rIns="0" bIns="0" rtlCol="0" anchor="ctr"/>
-          <a:lstStyle/>
-          <a:p>
-            <a:pPr algn="l" indent="0" marL="0">
-              <a:buNone/>
-            </a:pPr>
-            <a:r>
-              <a:rPr lang="en-US" sz="1150" dirty="0">
-                <a:solidFill>
-                  <a:srgbClr val="33393D"/>
-                </a:solidFill>
-                <a:latin typeface="Calibri" pitchFamily="34" charset="0"/>
-                <a:ea typeface="Calibri" pitchFamily="34" charset="-122"/>
-                <a:cs typeface="Calibri" pitchFamily="34" charset="-120"/>
-              </a:rPr>
-              <a:t>Sin errores</a:t>
-            </a:r>
-            <a:endParaRPr lang="en-US" sz="1150" dirty="0"/>
-          </a:p>
-        </p:txBody>
-      </p:sp>
-      <p:sp>
-        <p:nvSpPr>
-          <p:cNvPr id="28" name="Shape 26"/>
+          <p:cNvPr id="30" name="Shape 28"/>
           <p:cNvSpPr/>
           <p:nvPr/>
         </p:nvSpPr>
         <p:spPr>
           <a:xfrm>
-            <a:off x="640080" y="5440680"/>
-            <a:ext cx="10927080" cy="457200"/>
+            <a:off x="8046720" y="4352544"/>
+            <a:ext cx="3520440" cy="1572768"/>
           </a:xfrm>
           <a:prstGeom prst="roundRect">
             <a:avLst>
-              <a:gd name="adj" fmla="val 20000"/>
+              <a:gd name="adj" fmla="val 5814"/>
             </a:avLst>
           </a:prstGeom>
           <a:solidFill>
-            <a:srgbClr val="E6F8FA"/>
+            <a:srgbClr val="FFFFFF"/>
           </a:solidFill>
           <a:ln w="12700">
             <a:solidFill>
@@ -11303,30 +12074,94 @@
       </p:sp>
       <p:sp>
         <p:nvSpPr>
-          <p:cNvPr id="29" name="Text 27"/>
-          <p:cNvSpPr txBox="1"/>
-          <p:nvPr/>
-        </p:nvSpPr>
-        <p:spPr>
-          <a:xfrm>
-            <a:off x="868680" y="5440680"/>
-            <a:ext cx="1325880" cy="457200"/>
-          </a:xfrm>
-          <a:prstGeom prst="rect">
-            <a:avLst/>
-          </a:prstGeom>
-          <a:noFill/>
-          <a:ln/>
-        </p:spPr>
-        <p:txBody>
-          <a:bodyPr wrap="square" lIns="0" tIns="0" rIns="0" bIns="0" rtlCol="0" anchor="ctr"/>
-          <a:lstStyle/>
-          <a:p>
-            <a:pPr algn="l" indent="0" marL="0">
-              <a:buNone/>
-            </a:pPr>
-            <a:r>
-              <a:rPr lang="en-US" sz="1150" b="1" dirty="0">
+          <p:cNvPr id="31" name="Shape 29"/>
+          <p:cNvSpPr/>
+          <p:nvPr/>
+        </p:nvSpPr>
+        <p:spPr>
+          <a:xfrm>
+            <a:off x="8293608" y="4581144"/>
+            <a:ext cx="402336" cy="402336"/>
+          </a:xfrm>
+          <a:prstGeom prst="ellipse">
+            <a:avLst/>
+          </a:prstGeom>
+          <a:solidFill>
+            <a:srgbClr val="177E89"/>
+          </a:solidFill>
+          <a:ln w="12700">
+            <a:solidFill>
+              <a:srgbClr val="177E89"/>
+            </a:solidFill>
+            <a:prstDash val="solid"/>
+          </a:ln>
+        </p:spPr>
+      </p:sp>
+      <p:sp>
+        <p:nvSpPr>
+          <p:cNvPr id="32" name="Text 30"/>
+          <p:cNvSpPr txBox="1"/>
+          <p:nvPr/>
+        </p:nvSpPr>
+        <p:spPr>
+          <a:xfrm>
+            <a:off x="8293608" y="4581144"/>
+            <a:ext cx="402336" cy="402336"/>
+          </a:xfrm>
+          <a:prstGeom prst="rect">
+            <a:avLst/>
+          </a:prstGeom>
+          <a:noFill/>
+          <a:ln/>
+        </p:spPr>
+        <p:txBody>
+          <a:bodyPr wrap="square" lIns="0" tIns="0" rIns="0" bIns="0" rtlCol="0" anchor="ctr"/>
+          <a:lstStyle/>
+          <a:p>
+            <a:pPr algn="ctr" indent="0" marL="0">
+              <a:buNone/>
+            </a:pPr>
+            <a:r>
+              <a:rPr lang="en-US" sz="1200" b="1" dirty="0">
+                <a:solidFill>
+                  <a:srgbClr val="FFFFFF"/>
+                </a:solidFill>
+                <a:latin typeface="Calibri" pitchFamily="34" charset="0"/>
+                <a:ea typeface="Calibri" pitchFamily="34" charset="-122"/>
+                <a:cs typeface="Calibri" pitchFamily="34" charset="-120"/>
+              </a:rPr>
+              <a:t>6</a:t>
+            </a:r>
+            <a:endParaRPr lang="en-US" sz="1200" dirty="0"/>
+          </a:p>
+        </p:txBody>
+      </p:sp>
+      <p:sp>
+        <p:nvSpPr>
+          <p:cNvPr id="33" name="Text 31"/>
+          <p:cNvSpPr txBox="1"/>
+          <p:nvPr/>
+        </p:nvSpPr>
+        <p:spPr>
+          <a:xfrm>
+            <a:off x="8851392" y="4581144"/>
+            <a:ext cx="2560320" cy="402336"/>
+          </a:xfrm>
+          <a:prstGeom prst="rect">
+            <a:avLst/>
+          </a:prstGeom>
+          <a:noFill/>
+          <a:ln/>
+        </p:spPr>
+        <p:txBody>
+          <a:bodyPr wrap="square" lIns="0" tIns="0" rIns="0" bIns="0" rtlCol="0" anchor="ctr"/>
+          <a:lstStyle/>
+          <a:p>
+            <a:pPr algn="l" indent="0" marL="0">
+              <a:buNone/>
+            </a:pPr>
+            <a:r>
+              <a:rPr lang="en-US" sz="1300" b="1" dirty="0">
                 <a:solidFill>
                   <a:srgbClr val="1F2326"/>
                 </a:solidFill>
@@ -11334,7 +12169,46 @@
                 <a:ea typeface="Calibri" pitchFamily="34" charset="-122"/>
                 <a:cs typeface="Calibri" pitchFamily="34" charset="-120"/>
               </a:rPr>
-              <a:t>75 a 80</a:t>
+              <a:t>IA bien usada</a:t>
+            </a:r>
+            <a:endParaRPr lang="en-US" sz="1300" dirty="0"/>
+          </a:p>
+        </p:txBody>
+      </p:sp>
+      <p:sp>
+        <p:nvSpPr>
+          <p:cNvPr id="34" name="Text 32"/>
+          <p:cNvSpPr txBox="1"/>
+          <p:nvPr/>
+        </p:nvSpPr>
+        <p:spPr>
+          <a:xfrm>
+            <a:off x="8321040" y="5120640"/>
+            <a:ext cx="2971800" cy="676656"/>
+          </a:xfrm>
+          <a:prstGeom prst="rect">
+            <a:avLst/>
+          </a:prstGeom>
+          <a:noFill/>
+          <a:ln/>
+        </p:spPr>
+        <p:txBody>
+          <a:bodyPr wrap="square" lIns="0" tIns="0" rIns="0" bIns="0" rtlCol="0" anchor="t"/>
+          <a:lstStyle/>
+          <a:p>
+            <a:pPr algn="l" indent="0" marL="0">
+              <a:buNone/>
+            </a:pPr>
+            <a:r>
+              <a:rPr lang="en-US" sz="1150" dirty="0">
+                <a:solidFill>
+                  <a:srgbClr val="33393D"/>
+                </a:solidFill>
+                <a:latin typeface="Calibri" pitchFamily="34" charset="0"/>
+                <a:ea typeface="Calibri" pitchFamily="34" charset="-122"/>
+                <a:cs typeface="Calibri" pitchFamily="34" charset="-120"/>
+              </a:rPr>
+              <a:t>Se valora: muestra qué corregiste. Un código que no puedes explicar resta.</a:t>
             </a:r>
             <a:endParaRPr lang="en-US" sz="1150" dirty="0"/>
           </a:p>
@@ -11342,85 +12216,7 @@
       </p:sp>
       <p:sp>
         <p:nvSpPr>
-          <p:cNvPr id="30" name="Text 28"/>
-          <p:cNvSpPr txBox="1"/>
-          <p:nvPr/>
-        </p:nvSpPr>
-        <p:spPr>
-          <a:xfrm>
-            <a:off x="2331720" y="5440680"/>
-            <a:ext cx="6537960" cy="457200"/>
-          </a:xfrm>
-          <a:prstGeom prst="rect">
-            <a:avLst/>
-          </a:prstGeom>
-          <a:noFill/>
-          <a:ln/>
-        </p:spPr>
-        <p:txBody>
-          <a:bodyPr wrap="square" lIns="0" tIns="0" rIns="0" bIns="0" rtlCol="0" anchor="ctr"/>
-          <a:lstStyle/>
-          <a:p>
-            <a:pPr algn="l" indent="0" marL="0">
-              <a:buNone/>
-            </a:pPr>
-            <a:r>
-              <a:rPr lang="en-US" sz="1150" dirty="0">
-                <a:solidFill>
-                  <a:srgbClr val="33393D"/>
-                </a:solidFill>
-                <a:latin typeface="Calibri" pitchFamily="34" charset="0"/>
-                <a:ea typeface="Calibri" pitchFamily="34" charset="-122"/>
-                <a:cs typeface="Calibri" pitchFamily="34" charset="-120"/>
-              </a:rPr>
-              <a:t>Comprime apellido-nombre-ef y súbela al Aula Virtual</a:t>
-            </a:r>
-            <a:endParaRPr lang="en-US" sz="1150" dirty="0"/>
-          </a:p>
-        </p:txBody>
-      </p:sp>
-      <p:sp>
-        <p:nvSpPr>
-          <p:cNvPr id="31" name="Text 29"/>
-          <p:cNvSpPr txBox="1"/>
-          <p:nvPr/>
-        </p:nvSpPr>
-        <p:spPr>
-          <a:xfrm>
-            <a:off x="9006840" y="5440680"/>
-            <a:ext cx="2651760" cy="457200"/>
-          </a:xfrm>
-          <a:prstGeom prst="rect">
-            <a:avLst/>
-          </a:prstGeom>
-          <a:noFill/>
-          <a:ln/>
-        </p:spPr>
-        <p:txBody>
-          <a:bodyPr wrap="square" lIns="0" tIns="0" rIns="0" bIns="0" rtlCol="0" anchor="ctr"/>
-          <a:lstStyle/>
-          <a:p>
-            <a:pPr algn="l" indent="0" marL="0">
-              <a:buNone/>
-            </a:pPr>
-            <a:r>
-              <a:rPr lang="en-US" sz="1150" dirty="0">
-                <a:solidFill>
-                  <a:srgbClr val="33393D"/>
-                </a:solidFill>
-                <a:latin typeface="Calibri" pitchFamily="34" charset="0"/>
-                <a:ea typeface="Calibri" pitchFamily="34" charset="-122"/>
-                <a:cs typeface="Calibri" pitchFamily="34" charset="-120"/>
-              </a:rPr>
-              <a:t>Entrega</a:t>
-            </a:r>
-            <a:endParaRPr lang="en-US" sz="1150" dirty="0"/>
-          </a:p>
-        </p:txBody>
-      </p:sp>
-      <p:sp>
-        <p:nvSpPr>
-          <p:cNvPr id="32" name="Text 30"/>
+          <p:cNvPr id="35" name="Text 33"/>
           <p:cNvSpPr txBox="1"/>
           <p:nvPr/>
         </p:nvSpPr>
@@ -11747,7 +12543,7 @@
                 <a:ea typeface="Calibri" pitchFamily="34" charset="-122"/>
                 <a:cs typeface="Calibri" pitchFamily="34" charset="-120"/>
               </a:rPr>
-              <a:t>Sesiones 1 a 16 · Parte A: cuestionario · Parte B: caso práctico · 30 % del promedio</a:t>
+              <a:t>Sesiones 1 a 16 · Parte A: cuestionario · Parte B: presentación del proyecto · 30 % del promedio</a:t>
             </a:r>
             <a:endParaRPr lang="en-US" sz="1250" dirty="0"/>
           </a:p>
@@ -16541,7 +17337,7 @@
                 <a:ea typeface="Calibri" pitchFamily="34" charset="-122"/>
                 <a:cs typeface="Calibri" pitchFamily="34" charset="-120"/>
               </a:rPr>
-              <a:t>20 min</a:t>
+              <a:t>15 min</a:t>
             </a:r>
             <a:endParaRPr lang="en-US" sz="1100" dirty="0"/>
           </a:p>
@@ -17048,7 +17844,7 @@
                 <a:ea typeface="Calibri" pitchFamily="34" charset="-122"/>
                 <a:cs typeface="Calibri" pitchFamily="34" charset="-120"/>
               </a:rPr>
-              <a:t>Parte B · Caso práctico</a:t>
+              <a:t>Parte B · Presentaciones</a:t>
             </a:r>
             <a:endParaRPr lang="en-US" sz="1300" dirty="0"/>
           </a:p>
@@ -17087,7 +17883,7 @@
                 <a:ea typeface="Calibri" pitchFamily="34" charset="-122"/>
                 <a:cs typeface="Calibri" pitchFamily="34" charset="-120"/>
               </a:rPr>
-              <a:t>La página Semana de la Informática 2026.</a:t>
+              <a:t>Cada proyecto: 5 minutos y 2 de preguntas.</a:t>
             </a:r>
             <a:endParaRPr lang="en-US" sz="1100" dirty="0"/>
           </a:p>
@@ -17126,7 +17922,7 @@
                 <a:ea typeface="Calibri" pitchFamily="34" charset="-122"/>
                 <a:cs typeface="Calibri" pitchFamily="34" charset="-120"/>
               </a:rPr>
-              <a:t>80 min</a:t>
+              <a:t>115 min</a:t>
             </a:r>
             <a:endParaRPr lang="en-US" sz="1100" dirty="0"/>
           </a:p>
@@ -17517,7 +18313,7 @@
                 <a:ea typeface="Calibri" pitchFamily="34" charset="-122"/>
                 <a:cs typeface="Calibri" pitchFamily="34" charset="-120"/>
               </a:rPr>
-              <a:t>Individual, en el Aula Virtual USS, jueves 05/11/2026. Vale el 30 % de tu promedio final.</a:t>
+              <a:t>Individual, jueves 05/11/2026: el cuestionario en el Aula Virtual y la presentación en clase. Vale el 30 %.</a:t>
             </a:r>
             <a:endParaRPr lang="en-US" sz="1250" dirty="0"/>
           </a:p>
@@ -17755,7 +18551,7 @@
                 <a:ea typeface="Calibri" pitchFamily="34" charset="-122"/>
                 <a:cs typeface="Calibri" pitchFamily="34" charset="-120"/>
               </a:rPr>
-              <a:t>Parte B · Caso práctico · 10 puntos</a:t>
+              <a:t>Parte B · Presentación · 10 puntos</a:t>
             </a:r>
             <a:endParaRPr lang="en-US" sz="1400" dirty="0"/>
           </a:p>
@@ -17798,7 +18594,7 @@
                 <a:ea typeface="Calibri" pitchFamily="34" charset="-122"/>
                 <a:cs typeface="Calibri" pitchFamily="34" charset="-120"/>
               </a:rPr>
-              <a:t>Una página según su ficha técnica.</a:t>
+              <a:t>Tu proyecto integrador, publicado en Netlify.</a:t>
             </a:r>
             <a:endParaRPr lang="en-US" sz="1200" dirty="0"/>
           </a:p>
@@ -17819,7 +18615,7 @@
                 <a:ea typeface="Calibri" pitchFamily="34" charset="-122"/>
                 <a:cs typeface="Calibri" pitchFamily="34" charset="-120"/>
               </a:rPr>
-              <a:t>HTML semántico, CSS externo y diseño adaptable.</a:t>
+              <a:t>5 minutos de presentación y 2 de preguntas.</a:t>
             </a:r>
             <a:endParaRPr lang="en-US" sz="1200" dirty="0"/>
           </a:p>
@@ -17840,7 +18636,7 @@
                 <a:ea typeface="Calibri" pitchFamily="34" charset="-122"/>
                 <a:cs typeface="Calibri" pitchFamily="34" charset="-120"/>
               </a:rPr>
-              <a:t>80 minutos.</a:t>
+              <a:t>Muestras tu Figma, tu sitio y tu bitácora de prompts.</a:t>
             </a:r>
             <a:endParaRPr lang="en-US" sz="1200" dirty="0"/>
           </a:p>
@@ -17861,43 +18657,7 @@
                 <a:ea typeface="Calibri" pitchFamily="34" charset="-122"/>
                 <a:cs typeface="Calibri" pitchFamily="34" charset="-120"/>
               </a:rPr>
-              <a:t>Se entrega </a:t>
-            </a:r>
-            <a:pPr algn="l" marL="177800" indent="-177800">
-              <a:spcAft>
-                <a:spcPts val="400"/>
-              </a:spcAft>
-              <a:buSzPct val="100000"/>
-              <a:buChar char="•"/>
-            </a:pPr>
-            <a:r>
-              <a:rPr lang="en-US" sz="1200" dirty="0">
-                <a:solidFill>
-                  <a:srgbClr val="1F2326"/>
-                </a:solidFill>
-                <a:latin typeface="Consolas" pitchFamily="34" charset="0"/>
-                <a:ea typeface="Consolas" pitchFamily="34" charset="-122"/>
-                <a:cs typeface="Consolas" pitchFamily="34" charset="-120"/>
-              </a:rPr>
-              <a:t>apellido-nombre-ef.zip</a:t>
-            </a:r>
-            <a:pPr algn="l" marL="177800" indent="-177800">
-              <a:spcAft>
-                <a:spcPts val="400"/>
-              </a:spcAft>
-              <a:buSzPct val="100000"/>
-              <a:buChar char="•"/>
-            </a:pPr>
-            <a:r>
-              <a:rPr lang="en-US" sz="1200" dirty="0">
-                <a:solidFill>
-                  <a:srgbClr val="33393D"/>
-                </a:solidFill>
-                <a:latin typeface="Calibri" pitchFamily="34" charset="0"/>
-                <a:ea typeface="Calibri" pitchFamily="34" charset="-122"/>
-                <a:cs typeface="Calibri" pitchFamily="34" charset="-120"/>
-              </a:rPr>
-              <a:t> en el Aula Virtual.</a:t>
+              <a:t>Se califica con la pauta de presentación.</a:t>
             </a:r>
             <a:endParaRPr lang="en-US" sz="1200" dirty="0"/>
           </a:p>
@@ -18498,7 +19258,7 @@
                 <a:ea typeface="Calibri" pitchFamily="34" charset="-122"/>
                 <a:cs typeface="Calibri" pitchFamily="34" charset="-120"/>
               </a:rPr>
-              <a:t>Cada parte se cierra a la hora indicada, aunque no hayas terminado.</a:t>
+              <a:t>El cuestionario se cierra a la hora indicada. Cada presentación dura 7 minutos.</a:t>
             </a:r>
             <a:endParaRPr lang="en-US" sz="1150" dirty="0"/>
           </a:p>
@@ -18628,7 +19388,7 @@
                 <a:ea typeface="Calibri" pitchFamily="34" charset="-122"/>
                 <a:cs typeface="Calibri" pitchFamily="34" charset="-120"/>
               </a:rPr>
-              <a:t>Puedes consultar</a:t>
+              <a:t>Parte A sin consulta</a:t>
             </a:r>
             <a:endParaRPr lang="en-US" sz="1300" dirty="0"/>
           </a:p>
@@ -18667,7 +19427,7 @@
                 <a:ea typeface="Calibri" pitchFamily="34" charset="-122"/>
                 <a:cs typeface="Calibri" pitchFamily="34" charset="-120"/>
               </a:rPr>
-              <a:t>Tu portafolio, las guías del curso, MDN y getbootstrap.com.</a:t>
+              <a:t>El cuestionario es individual: cierra tus apuntes y tu portafolio.</a:t>
             </a:r>
             <a:endParaRPr lang="en-US" sz="1150" dirty="0"/>
           </a:p>
@@ -18966,7 +19726,7 @@
                 <a:ea typeface="Calibri" pitchFamily="34" charset="-122"/>
                 <a:cs typeface="Calibri" pitchFamily="34" charset="-120"/>
               </a:rPr>
-              <a:t>Originalidad</a:t>
+              <a:t>IA con bitácora</a:t>
             </a:r>
             <a:endParaRPr lang="en-US" sz="1300" dirty="0"/>
           </a:p>
@@ -19005,7 +19765,7 @@
                 <a:ea typeface="Calibri" pitchFamily="34" charset="-122"/>
                 <a:cs typeface="Calibri" pitchFamily="34" charset="-120"/>
               </a:rPr>
-              <a:t>Los trabajos iguales entre sí o hechos por terceros se califican con cero.</a:t>
+              <a:t>Puedes usar IA si la registras en tu bitácora y sabes explicar tu código.</a:t>
             </a:r>
             <a:endParaRPr lang="en-US" sz="1150" dirty="0"/>
           </a:p>
@@ -19135,7 +19895,7 @@
                 <a:ea typeface="Calibri" pitchFamily="34" charset="-122"/>
                 <a:cs typeface="Calibri" pitchFamily="34" charset="-120"/>
               </a:rPr>
-              <a:t>Entrega</a:t>
+              <a:t>Entrega previa</a:t>
             </a:r>
             <a:endParaRPr lang="en-US" sz="1300" dirty="0"/>
           </a:p>
@@ -19174,63 +19934,7 @@
                 <a:ea typeface="Calibri" pitchFamily="34" charset="-122"/>
                 <a:cs typeface="Calibri" pitchFamily="34" charset="-120"/>
               </a:rPr>
-              <a:t>Revisa que el </a:t>
-            </a:r>
-            <a:pPr algn="l" indent="0" marL="0">
-              <a:buNone/>
-            </a:pPr>
-            <a:r>
-              <a:rPr lang="en-US" sz="1150" dirty="0">
-                <a:solidFill>
-                  <a:srgbClr val="1F2326"/>
-                </a:solidFill>
-                <a:latin typeface="Consolas" pitchFamily="34" charset="0"/>
-                <a:ea typeface="Consolas" pitchFamily="34" charset="-122"/>
-                <a:cs typeface="Consolas" pitchFamily="34" charset="-120"/>
-              </a:rPr>
-              <a:t>.zip</a:t>
-            </a:r>
-            <a:pPr algn="l" indent="0" marL="0">
-              <a:buNone/>
-            </a:pPr>
-            <a:r>
-              <a:rPr lang="en-US" sz="1150" dirty="0">
-                <a:solidFill>
-                  <a:srgbClr val="33393D"/>
-                </a:solidFill>
-                <a:latin typeface="Calibri" pitchFamily="34" charset="0"/>
-                <a:ea typeface="Calibri" pitchFamily="34" charset="-122"/>
-                <a:cs typeface="Calibri" pitchFamily="34" charset="-120"/>
-              </a:rPr>
-              <a:t> tenga </a:t>
-            </a:r>
-            <a:pPr algn="l" indent="0" marL="0">
-              <a:buNone/>
-            </a:pPr>
-            <a:r>
-              <a:rPr lang="en-US" sz="1150" dirty="0">
-                <a:solidFill>
-                  <a:srgbClr val="1F2326"/>
-                </a:solidFill>
-                <a:latin typeface="Consolas" pitchFamily="34" charset="0"/>
-                <a:ea typeface="Consolas" pitchFamily="34" charset="-122"/>
-                <a:cs typeface="Consolas" pitchFamily="34" charset="-120"/>
-              </a:rPr>
-              <a:t>index.html</a:t>
-            </a:r>
-            <a:pPr algn="l" indent="0" marL="0">
-              <a:buNone/>
-            </a:pPr>
-            <a:r>
-              <a:rPr lang="en-US" sz="1150" dirty="0">
-                <a:solidFill>
-                  <a:srgbClr val="33393D"/>
-                </a:solidFill>
-                <a:latin typeface="Calibri" pitchFamily="34" charset="0"/>
-                <a:ea typeface="Calibri" pitchFamily="34" charset="-122"/>
-                <a:cs typeface="Calibri" pitchFamily="34" charset="-120"/>
-              </a:rPr>
-              <a:t> en su raíz antes de subirlo.</a:t>
+              <a:t>Tu proyecto y tu bitácora ya están en el Aula Virtual antes de empezar.</a:t>
             </a:r>
             <a:endParaRPr lang="en-US" sz="1150" dirty="0"/>
           </a:p>
@@ -19987,7 +20691,7 @@
                 <a:ea typeface="Calibri" pitchFamily="34" charset="-122"/>
                 <a:cs typeface="Calibri" pitchFamily="34" charset="-120"/>
               </a:rPr>
-              <a:t>La estructura que escribes al empezar la Parte B.</a:t>
+              <a:t>La estructura de cualquier página del curso.</a:t>
             </a:r>
             <a:endParaRPr lang="en-US" sz="1250" dirty="0"/>
           </a:p>

</xml_diff>